<commit_message>
Update P10_Team30_Digital Banking presentation deck
</commit_message>
<xml_diff>
--- a/P10_Team30_Digital Banking.pptx
+++ b/P10_Team30_Digital Banking.pptx
@@ -316,7 +316,7 @@
       </p15:sldGuideLst>
     </p:ext>
     <p:ext uri="GoogleSlidesCustomDataVersion2">
-      <go:slidesCustomData xmlns:go="http://customooxmlschemas.google.com/" r:id="rId44" roundtripDataSignature="AMtx7mjvN48dcfPyWkVV0V0B0ziHnkCq+Q=="/>
+      <go:slidesCustomData xmlns:go="http://customooxmlschemas.google.com/" r:id="rId44" roundtripDataSignature="AMtx7miHWp8dPNsCvdRlvPQtZf5E8KhVaQ=="/>
     </p:ext>
   </p:extLst>
 </p:presentation>
@@ -852,7 +852,7 @@
   <p:cSld>
     <p:spTree>
       <p:nvGrpSpPr>
-        <p:cNvPr id="374" name="Shape 374"/>
+        <p:cNvPr id="367" name="Shape 367"/>
         <p:cNvGrpSpPr/>
         <p:nvPr/>
       </p:nvGrpSpPr>
@@ -866,7 +866,7 @@
       </p:grpSpPr>
       <p:sp>
         <p:nvSpPr>
-          <p:cNvPr id="375" name="Google Shape;375;p10:notes"/>
+          <p:cNvPr id="368" name="Google Shape;368;p10:notes"/>
           <p:cNvSpPr txBox="1"/>
           <p:nvPr>
             <p:ph idx="1" type="body"/>
@@ -905,7 +905,7 @@
       </p:sp>
       <p:sp>
         <p:nvSpPr>
-          <p:cNvPr id="376" name="Google Shape;376;p10:notes"/>
+          <p:cNvPr id="369" name="Google Shape;369;p10:notes"/>
           <p:cNvSpPr/>
           <p:nvPr>
             <p:ph idx="2" type="sldImg"/>
@@ -951,7 +951,7 @@
   <p:cSld>
     <p:spTree>
       <p:nvGrpSpPr>
-        <p:cNvPr id="420" name="Shape 420"/>
+        <p:cNvPr id="413" name="Shape 413"/>
         <p:cNvGrpSpPr/>
         <p:nvPr/>
       </p:nvGrpSpPr>
@@ -965,7 +965,7 @@
       </p:grpSpPr>
       <p:sp>
         <p:nvSpPr>
-          <p:cNvPr id="421" name="Google Shape;421;g38b9b130855_2_702:notes"/>
+          <p:cNvPr id="414" name="Google Shape;414;g38b9b130855_2_702:notes"/>
           <p:cNvSpPr/>
           <p:nvPr>
             <p:ph idx="2" type="sldImg"/>
@@ -1000,7 +1000,7 @@
       </p:sp>
       <p:sp>
         <p:nvSpPr>
-          <p:cNvPr id="422" name="Google Shape;422;g38b9b130855_2_702:notes"/>
+          <p:cNvPr id="415" name="Google Shape;415;g38b9b130855_2_702:notes"/>
           <p:cNvSpPr txBox="1"/>
           <p:nvPr>
             <p:ph idx="1" type="body"/>
@@ -1248,7 +1248,7 @@
   <p:cSld>
     <p:spTree>
       <p:nvGrpSpPr>
-        <p:cNvPr id="163" name="Shape 163"/>
+        <p:cNvPr id="159" name="Shape 159"/>
         <p:cNvGrpSpPr/>
         <p:nvPr/>
       </p:nvGrpSpPr>
@@ -1262,7 +1262,7 @@
       </p:grpSpPr>
       <p:sp>
         <p:nvSpPr>
-          <p:cNvPr id="164" name="Google Shape;164;p4:notes"/>
+          <p:cNvPr id="160" name="Google Shape;160;p4:notes"/>
           <p:cNvSpPr txBox="1"/>
           <p:nvPr>
             <p:ph idx="1" type="body"/>
@@ -1301,7 +1301,7 @@
       </p:sp>
       <p:sp>
         <p:nvSpPr>
-          <p:cNvPr id="165" name="Google Shape;165;p4:notes"/>
+          <p:cNvPr id="161" name="Google Shape;161;p4:notes"/>
           <p:cNvSpPr/>
           <p:nvPr>
             <p:ph idx="2" type="sldImg"/>
@@ -1347,7 +1347,7 @@
   <p:cSld>
     <p:spTree>
       <p:nvGrpSpPr>
-        <p:cNvPr id="200" name="Shape 200"/>
+        <p:cNvPr id="196" name="Shape 196"/>
         <p:cNvGrpSpPr/>
         <p:nvPr/>
       </p:nvGrpSpPr>
@@ -1361,7 +1361,7 @@
       </p:grpSpPr>
       <p:sp>
         <p:nvSpPr>
-          <p:cNvPr id="201" name="Google Shape;201;p5:notes"/>
+          <p:cNvPr id="197" name="Google Shape;197;p5:notes"/>
           <p:cNvSpPr txBox="1"/>
           <p:nvPr>
             <p:ph idx="1" type="body"/>
@@ -1400,7 +1400,7 @@
       </p:sp>
       <p:sp>
         <p:nvSpPr>
-          <p:cNvPr id="202" name="Google Shape;202;p5:notes"/>
+          <p:cNvPr id="198" name="Google Shape;198;p5:notes"/>
           <p:cNvSpPr/>
           <p:nvPr>
             <p:ph idx="2" type="sldImg"/>
@@ -1446,7 +1446,7 @@
   <p:cSld>
     <p:spTree>
       <p:nvGrpSpPr>
-        <p:cNvPr id="218" name="Shape 218"/>
+        <p:cNvPr id="214" name="Shape 214"/>
         <p:cNvGrpSpPr/>
         <p:nvPr/>
       </p:nvGrpSpPr>
@@ -1460,7 +1460,7 @@
       </p:grpSpPr>
       <p:sp>
         <p:nvSpPr>
-          <p:cNvPr id="219" name="Google Shape;219;p6:notes"/>
+          <p:cNvPr id="215" name="Google Shape;215;p6:notes"/>
           <p:cNvSpPr txBox="1"/>
           <p:nvPr>
             <p:ph idx="1" type="body"/>
@@ -1499,7 +1499,7 @@
       </p:sp>
       <p:sp>
         <p:nvSpPr>
-          <p:cNvPr id="220" name="Google Shape;220;p6:notes"/>
+          <p:cNvPr id="216" name="Google Shape;216;p6:notes"/>
           <p:cNvSpPr/>
           <p:nvPr>
             <p:ph idx="2" type="sldImg"/>
@@ -1545,7 +1545,7 @@
   <p:cSld>
     <p:spTree>
       <p:nvGrpSpPr>
-        <p:cNvPr id="262" name="Shape 262"/>
+        <p:cNvPr id="255" name="Shape 255"/>
         <p:cNvGrpSpPr/>
         <p:nvPr/>
       </p:nvGrpSpPr>
@@ -1559,7 +1559,7 @@
       </p:grpSpPr>
       <p:sp>
         <p:nvSpPr>
-          <p:cNvPr id="263" name="Google Shape;263;p7:notes"/>
+          <p:cNvPr id="256" name="Google Shape;256;p7:notes"/>
           <p:cNvSpPr txBox="1"/>
           <p:nvPr>
             <p:ph idx="1" type="body"/>
@@ -1598,7 +1598,7 @@
       </p:sp>
       <p:sp>
         <p:nvSpPr>
-          <p:cNvPr id="264" name="Google Shape;264;p7:notes"/>
+          <p:cNvPr id="257" name="Google Shape;257;p7:notes"/>
           <p:cNvSpPr/>
           <p:nvPr>
             <p:ph idx="2" type="sldImg"/>
@@ -1644,7 +1644,7 @@
   <p:cSld>
     <p:spTree>
       <p:nvGrpSpPr>
-        <p:cNvPr id="308" name="Shape 308"/>
+        <p:cNvPr id="301" name="Shape 301"/>
         <p:cNvGrpSpPr/>
         <p:nvPr/>
       </p:nvGrpSpPr>
@@ -1658,7 +1658,7 @@
       </p:grpSpPr>
       <p:sp>
         <p:nvSpPr>
-          <p:cNvPr id="309" name="Google Shape;309;p8:notes"/>
+          <p:cNvPr id="302" name="Google Shape;302;p8:notes"/>
           <p:cNvSpPr txBox="1"/>
           <p:nvPr>
             <p:ph idx="1" type="body"/>
@@ -1697,7 +1697,7 @@
       </p:sp>
       <p:sp>
         <p:nvSpPr>
-          <p:cNvPr id="310" name="Google Shape;310;p8:notes"/>
+          <p:cNvPr id="303" name="Google Shape;303;p8:notes"/>
           <p:cNvSpPr/>
           <p:nvPr>
             <p:ph idx="2" type="sldImg"/>
@@ -1743,7 +1743,7 @@
   <p:cSld>
     <p:spTree>
       <p:nvGrpSpPr>
-        <p:cNvPr id="342" name="Shape 342"/>
+        <p:cNvPr id="335" name="Shape 335"/>
         <p:cNvGrpSpPr/>
         <p:nvPr/>
       </p:nvGrpSpPr>
@@ -1757,7 +1757,7 @@
       </p:grpSpPr>
       <p:sp>
         <p:nvSpPr>
-          <p:cNvPr id="343" name="Google Shape;343;p9:notes"/>
+          <p:cNvPr id="336" name="Google Shape;336;p9:notes"/>
           <p:cNvSpPr txBox="1"/>
           <p:nvPr>
             <p:ph idx="1" type="body"/>
@@ -1796,7 +1796,7 @@
       </p:sp>
       <p:sp>
         <p:nvSpPr>
-          <p:cNvPr id="344" name="Google Shape;344;p9:notes"/>
+          <p:cNvPr id="337" name="Google Shape;337;p9:notes"/>
           <p:cNvSpPr/>
           <p:nvPr>
             <p:ph idx="2" type="sldImg"/>
@@ -11913,7 +11913,7 @@
   <p:cSld>
     <p:spTree>
       <p:nvGrpSpPr>
-        <p:cNvPr id="377" name="Shape 377"/>
+        <p:cNvPr id="370" name="Shape 370"/>
         <p:cNvGrpSpPr/>
         <p:nvPr/>
       </p:nvGrpSpPr>
@@ -11927,7 +11927,7 @@
       </p:grpSpPr>
       <p:pic>
         <p:nvPicPr>
-          <p:cNvPr descr="image.png" id="378" name="Google Shape;378;p10"/>
+          <p:cNvPr descr="image.png" id="371" name="Google Shape;371;p10"/>
           <p:cNvPicPr preferRelativeResize="0"/>
           <p:nvPr/>
         </p:nvPicPr>
@@ -11954,7 +11954,7 @@
       </p:pic>
       <p:pic>
         <p:nvPicPr>
-          <p:cNvPr descr="image.png" id="379" name="Google Shape;379;p10"/>
+          <p:cNvPr descr="image.png" id="372" name="Google Shape;372;p10"/>
           <p:cNvPicPr preferRelativeResize="0"/>
           <p:nvPr/>
         </p:nvPicPr>
@@ -11981,7 +11981,7 @@
       </p:pic>
       <p:pic>
         <p:nvPicPr>
-          <p:cNvPr descr="image.png" id="380" name="Google Shape;380;p10"/>
+          <p:cNvPr descr="image.png" id="373" name="Google Shape;373;p10"/>
           <p:cNvPicPr preferRelativeResize="0"/>
           <p:nvPr/>
         </p:nvPicPr>
@@ -12008,7 +12008,7 @@
       </p:pic>
       <p:pic>
         <p:nvPicPr>
-          <p:cNvPr descr="image.png" id="381" name="Google Shape;381;p10"/>
+          <p:cNvPr descr="image.png" id="374" name="Google Shape;374;p10"/>
           <p:cNvPicPr preferRelativeResize="0"/>
           <p:nvPr/>
         </p:nvPicPr>
@@ -12035,7 +12035,7 @@
       </p:pic>
       <p:pic>
         <p:nvPicPr>
-          <p:cNvPr descr="image.png" id="382" name="Google Shape;382;p10"/>
+          <p:cNvPr descr="image.png" id="375" name="Google Shape;375;p10"/>
           <p:cNvPicPr preferRelativeResize="0"/>
           <p:nvPr/>
         </p:nvPicPr>
@@ -12062,7 +12062,7 @@
       </p:pic>
       <p:pic>
         <p:nvPicPr>
-          <p:cNvPr descr="image.png" id="383" name="Google Shape;383;p10"/>
+          <p:cNvPr descr="image.png" id="376" name="Google Shape;376;p10"/>
           <p:cNvPicPr preferRelativeResize="0"/>
           <p:nvPr/>
         </p:nvPicPr>
@@ -12089,7 +12089,7 @@
       </p:pic>
       <p:sp>
         <p:nvSpPr>
-          <p:cNvPr id="384" name="Google Shape;384;p10"/>
+          <p:cNvPr id="377" name="Google Shape;377;p10"/>
           <p:cNvSpPr txBox="1"/>
           <p:nvPr/>
         </p:nvSpPr>
@@ -12139,7 +12139,7 @@
       </p:sp>
       <p:sp>
         <p:nvSpPr>
-          <p:cNvPr id="385" name="Google Shape;385;p10"/>
+          <p:cNvPr id="378" name="Google Shape;378;p10"/>
           <p:cNvSpPr txBox="1"/>
           <p:nvPr/>
         </p:nvSpPr>
@@ -12189,7 +12189,7 @@
       </p:sp>
       <p:sp>
         <p:nvSpPr>
-          <p:cNvPr id="386" name="Google Shape;386;p10"/>
+          <p:cNvPr id="379" name="Google Shape;379;p10"/>
           <p:cNvSpPr txBox="1"/>
           <p:nvPr/>
         </p:nvSpPr>
@@ -12239,7 +12239,7 @@
       </p:sp>
       <p:sp>
         <p:nvSpPr>
-          <p:cNvPr id="387" name="Google Shape;387;p10"/>
+          <p:cNvPr id="380" name="Google Shape;380;p10"/>
           <p:cNvSpPr txBox="1"/>
           <p:nvPr/>
         </p:nvSpPr>
@@ -12289,7 +12289,7 @@
       </p:sp>
       <p:sp>
         <p:nvSpPr>
-          <p:cNvPr id="388" name="Google Shape;388;p10"/>
+          <p:cNvPr id="381" name="Google Shape;381;p10"/>
           <p:cNvSpPr txBox="1"/>
           <p:nvPr/>
         </p:nvSpPr>
@@ -12339,7 +12339,7 @@
       </p:sp>
       <p:sp>
         <p:nvSpPr>
-          <p:cNvPr id="389" name="Google Shape;389;p10"/>
+          <p:cNvPr id="382" name="Google Shape;382;p10"/>
           <p:cNvSpPr txBox="1"/>
           <p:nvPr/>
         </p:nvSpPr>
@@ -12389,7 +12389,7 @@
       </p:sp>
       <p:sp>
         <p:nvSpPr>
-          <p:cNvPr id="390" name="Google Shape;390;p10"/>
+          <p:cNvPr id="383" name="Google Shape;383;p10"/>
           <p:cNvSpPr/>
           <p:nvPr/>
         </p:nvSpPr>
@@ -12440,7 +12440,7 @@
       </p:sp>
       <p:sp>
         <p:nvSpPr>
-          <p:cNvPr id="391" name="Google Shape;391;p10"/>
+          <p:cNvPr id="384" name="Google Shape;384;p10"/>
           <p:cNvSpPr txBox="1"/>
           <p:nvPr/>
         </p:nvSpPr>
@@ -12490,7 +12490,7 @@
       </p:sp>
       <p:sp>
         <p:nvSpPr>
-          <p:cNvPr id="392" name="Google Shape;392;p10"/>
+          <p:cNvPr id="385" name="Google Shape;385;p10"/>
           <p:cNvSpPr txBox="1"/>
           <p:nvPr/>
         </p:nvSpPr>
@@ -12540,7 +12540,7 @@
       </p:sp>
       <p:sp>
         <p:nvSpPr>
-          <p:cNvPr id="393" name="Google Shape;393;p10"/>
+          <p:cNvPr id="386" name="Google Shape;386;p10"/>
           <p:cNvSpPr/>
           <p:nvPr/>
         </p:nvSpPr>
@@ -12591,7 +12591,7 @@
       </p:sp>
       <p:sp>
         <p:nvSpPr>
-          <p:cNvPr id="394" name="Google Shape;394;p10"/>
+          <p:cNvPr id="387" name="Google Shape;387;p10"/>
           <p:cNvSpPr txBox="1"/>
           <p:nvPr/>
         </p:nvSpPr>
@@ -12641,7 +12641,7 @@
       </p:sp>
       <p:sp>
         <p:nvSpPr>
-          <p:cNvPr id="395" name="Google Shape;395;p10"/>
+          <p:cNvPr id="388" name="Google Shape;388;p10"/>
           <p:cNvSpPr txBox="1"/>
           <p:nvPr/>
         </p:nvSpPr>
@@ -12691,7 +12691,7 @@
       </p:sp>
       <p:sp>
         <p:nvSpPr>
-          <p:cNvPr id="396" name="Google Shape;396;p10"/>
+          <p:cNvPr id="389" name="Google Shape;389;p10"/>
           <p:cNvSpPr/>
           <p:nvPr/>
         </p:nvSpPr>
@@ -12742,7 +12742,7 @@
       </p:sp>
       <p:sp>
         <p:nvSpPr>
-          <p:cNvPr id="397" name="Google Shape;397;p10"/>
+          <p:cNvPr id="390" name="Google Shape;390;p10"/>
           <p:cNvSpPr txBox="1"/>
           <p:nvPr/>
         </p:nvSpPr>
@@ -12795,7 +12795,7 @@
       </p:sp>
       <p:sp>
         <p:nvSpPr>
-          <p:cNvPr id="398" name="Google Shape;398;p10"/>
+          <p:cNvPr id="391" name="Google Shape;391;p10"/>
           <p:cNvSpPr txBox="1"/>
           <p:nvPr/>
         </p:nvSpPr>
@@ -12848,7 +12848,7 @@
       </p:sp>
       <p:sp>
         <p:nvSpPr>
-          <p:cNvPr id="399" name="Google Shape;399;p10"/>
+          <p:cNvPr id="392" name="Google Shape;392;p10"/>
           <p:cNvSpPr txBox="1"/>
           <p:nvPr/>
         </p:nvSpPr>
@@ -12901,7 +12901,7 @@
       </p:sp>
       <p:sp>
         <p:nvSpPr>
-          <p:cNvPr id="400" name="Google Shape;400;p10"/>
+          <p:cNvPr id="393" name="Google Shape;393;p10"/>
           <p:cNvSpPr txBox="1"/>
           <p:nvPr/>
         </p:nvSpPr>
@@ -12954,7 +12954,7 @@
       </p:sp>
       <p:sp>
         <p:nvSpPr>
-          <p:cNvPr id="401" name="Google Shape;401;p10"/>
+          <p:cNvPr id="394" name="Google Shape;394;p10"/>
           <p:cNvSpPr txBox="1"/>
           <p:nvPr/>
         </p:nvSpPr>
@@ -13007,7 +13007,7 @@
       </p:sp>
       <p:sp>
         <p:nvSpPr>
-          <p:cNvPr id="402" name="Google Shape;402;p10"/>
+          <p:cNvPr id="395" name="Google Shape;395;p10"/>
           <p:cNvSpPr txBox="1"/>
           <p:nvPr/>
         </p:nvSpPr>
@@ -13060,7 +13060,7 @@
       </p:sp>
       <p:sp>
         <p:nvSpPr>
-          <p:cNvPr id="403" name="Google Shape;403;p10"/>
+          <p:cNvPr id="396" name="Google Shape;396;p10"/>
           <p:cNvSpPr txBox="1"/>
           <p:nvPr/>
         </p:nvSpPr>
@@ -13113,7 +13113,7 @@
       </p:sp>
       <p:sp>
         <p:nvSpPr>
-          <p:cNvPr id="404" name="Google Shape;404;p10"/>
+          <p:cNvPr id="397" name="Google Shape;397;p10"/>
           <p:cNvSpPr txBox="1"/>
           <p:nvPr/>
         </p:nvSpPr>
@@ -13166,7 +13166,7 @@
       </p:sp>
       <p:sp>
         <p:nvSpPr>
-          <p:cNvPr id="405" name="Google Shape;405;p10"/>
+          <p:cNvPr id="398" name="Google Shape;398;p10"/>
           <p:cNvSpPr txBox="1"/>
           <p:nvPr/>
         </p:nvSpPr>
@@ -13219,7 +13219,7 @@
       </p:sp>
       <p:sp>
         <p:nvSpPr>
-          <p:cNvPr id="406" name="Google Shape;406;p10"/>
+          <p:cNvPr id="399" name="Google Shape;399;p10"/>
           <p:cNvSpPr txBox="1"/>
           <p:nvPr/>
         </p:nvSpPr>
@@ -13272,7 +13272,7 @@
       </p:sp>
       <p:pic>
         <p:nvPicPr>
-          <p:cNvPr descr="image.png" id="407" name="Google Shape;407;p10"/>
+          <p:cNvPr descr="image.png" id="400" name="Google Shape;400;p10"/>
           <p:cNvPicPr preferRelativeResize="0"/>
           <p:nvPr/>
         </p:nvPicPr>
@@ -13299,7 +13299,7 @@
       </p:pic>
       <p:pic>
         <p:nvPicPr>
-          <p:cNvPr descr="image.png" id="408" name="Google Shape;408;p10"/>
+          <p:cNvPr descr="image.png" id="401" name="Google Shape;401;p10"/>
           <p:cNvPicPr preferRelativeResize="0"/>
           <p:nvPr/>
         </p:nvPicPr>
@@ -13326,7 +13326,7 @@
       </p:pic>
       <p:pic>
         <p:nvPicPr>
-          <p:cNvPr descr="image.png" id="409" name="Google Shape;409;p10"/>
+          <p:cNvPr descr="image.png" id="402" name="Google Shape;402;p10"/>
           <p:cNvPicPr preferRelativeResize="0"/>
           <p:nvPr/>
         </p:nvPicPr>
@@ -13353,13 +13353,384 @@
       </p:pic>
       <p:sp>
         <p:nvSpPr>
+          <p:cNvPr id="403" name="Google Shape;403;p10"/>
+          <p:cNvSpPr txBox="1"/>
+          <p:nvPr/>
+        </p:nvSpPr>
+        <p:spPr>
+          <a:xfrm>
+            <a:off x="695325" y="3468737"/>
+            <a:ext cx="38100" cy="161925"/>
+          </a:xfrm>
+          <a:prstGeom prst="rect">
+            <a:avLst/>
+          </a:prstGeom>
+          <a:noFill/>
+          <a:ln>
+            <a:noFill/>
+          </a:ln>
+        </p:spPr>
+        <p:txBody>
+          <a:bodyPr anchorCtr="0" anchor="t" bIns="0" lIns="0" spcFirstLastPara="1" rIns="0" wrap="square" tIns="0">
+            <a:spAutoFit/>
+          </a:bodyPr>
+          <a:lstStyle/>
+          <a:p>
+            <a:pPr indent="0" lvl="0" marL="0" marR="0" rtl="0" algn="l">
+              <a:lnSpc>
+                <a:spcPct val="145000"/>
+              </a:lnSpc>
+              <a:spcBef>
+                <a:spcPts val="0"/>
+              </a:spcBef>
+              <a:spcAft>
+                <a:spcPts val="0"/>
+              </a:spcAft>
+              <a:buNone/>
+            </a:pPr>
+            <a:r>
+              <a:rPr b="0" i="0" lang="en-US" sz="900" u="none" cap="none" strike="noStrike">
+                <a:solidFill>
+                  <a:srgbClr val="C5A059"/>
+                </a:solidFill>
+                <a:latin typeface="DM Sans"/>
+                <a:ea typeface="DM Sans"/>
+                <a:cs typeface="DM Sans"/>
+                <a:sym typeface="DM Sans"/>
+              </a:rPr>
+              <a:t>▪</a:t>
+            </a:r>
+            <a:endParaRPr/>
+          </a:p>
+        </p:txBody>
+      </p:sp>
+      <p:sp>
+        <p:nvSpPr>
+          <p:cNvPr id="404" name="Google Shape;404;p10"/>
+          <p:cNvSpPr txBox="1"/>
+          <p:nvPr/>
+        </p:nvSpPr>
+        <p:spPr>
+          <a:xfrm>
+            <a:off x="695325" y="3926234"/>
+            <a:ext cx="38100" cy="161925"/>
+          </a:xfrm>
+          <a:prstGeom prst="rect">
+            <a:avLst/>
+          </a:prstGeom>
+          <a:noFill/>
+          <a:ln>
+            <a:noFill/>
+          </a:ln>
+        </p:spPr>
+        <p:txBody>
+          <a:bodyPr anchorCtr="0" anchor="t" bIns="0" lIns="0" spcFirstLastPara="1" rIns="0" wrap="square" tIns="0">
+            <a:spAutoFit/>
+          </a:bodyPr>
+          <a:lstStyle/>
+          <a:p>
+            <a:pPr indent="0" lvl="0" marL="0" marR="0" rtl="0" algn="l">
+              <a:lnSpc>
+                <a:spcPct val="145000"/>
+              </a:lnSpc>
+              <a:spcBef>
+                <a:spcPts val="0"/>
+              </a:spcBef>
+              <a:spcAft>
+                <a:spcPts val="0"/>
+              </a:spcAft>
+              <a:buNone/>
+            </a:pPr>
+            <a:r>
+              <a:rPr b="0" i="0" lang="en-US" sz="900" u="none" cap="none" strike="noStrike">
+                <a:solidFill>
+                  <a:srgbClr val="C5A059"/>
+                </a:solidFill>
+                <a:latin typeface="DM Sans"/>
+                <a:ea typeface="DM Sans"/>
+                <a:cs typeface="DM Sans"/>
+                <a:sym typeface="DM Sans"/>
+              </a:rPr>
+              <a:t>▪</a:t>
+            </a:r>
+            <a:endParaRPr/>
+          </a:p>
+        </p:txBody>
+      </p:sp>
+      <p:sp>
+        <p:nvSpPr>
+          <p:cNvPr id="405" name="Google Shape;405;p10"/>
+          <p:cNvSpPr txBox="1"/>
+          <p:nvPr/>
+        </p:nvSpPr>
+        <p:spPr>
+          <a:xfrm>
+            <a:off x="4505325" y="3011239"/>
+            <a:ext cx="38100" cy="161925"/>
+          </a:xfrm>
+          <a:prstGeom prst="rect">
+            <a:avLst/>
+          </a:prstGeom>
+          <a:noFill/>
+          <a:ln>
+            <a:noFill/>
+          </a:ln>
+        </p:spPr>
+        <p:txBody>
+          <a:bodyPr anchorCtr="0" anchor="t" bIns="0" lIns="0" spcFirstLastPara="1" rIns="0" wrap="square" tIns="0">
+            <a:spAutoFit/>
+          </a:bodyPr>
+          <a:lstStyle/>
+          <a:p>
+            <a:pPr indent="0" lvl="0" marL="0" marR="0" rtl="0" algn="l">
+              <a:lnSpc>
+                <a:spcPct val="145000"/>
+              </a:lnSpc>
+              <a:spcBef>
+                <a:spcPts val="0"/>
+              </a:spcBef>
+              <a:spcAft>
+                <a:spcPts val="0"/>
+              </a:spcAft>
+              <a:buNone/>
+            </a:pPr>
+            <a:r>
+              <a:rPr b="0" i="0" lang="en-US" sz="900" u="none" cap="none" strike="noStrike">
+                <a:solidFill>
+                  <a:srgbClr val="C5A059"/>
+                </a:solidFill>
+                <a:latin typeface="DM Sans"/>
+                <a:ea typeface="DM Sans"/>
+                <a:cs typeface="DM Sans"/>
+                <a:sym typeface="DM Sans"/>
+              </a:rPr>
+              <a:t>▪</a:t>
+            </a:r>
+            <a:endParaRPr/>
+          </a:p>
+        </p:txBody>
+      </p:sp>
+      <p:sp>
+        <p:nvSpPr>
+          <p:cNvPr id="406" name="Google Shape;406;p10"/>
+          <p:cNvSpPr txBox="1"/>
+          <p:nvPr/>
+        </p:nvSpPr>
+        <p:spPr>
+          <a:xfrm>
+            <a:off x="4505325" y="3468737"/>
+            <a:ext cx="38100" cy="161925"/>
+          </a:xfrm>
+          <a:prstGeom prst="rect">
+            <a:avLst/>
+          </a:prstGeom>
+          <a:noFill/>
+          <a:ln>
+            <a:noFill/>
+          </a:ln>
+        </p:spPr>
+        <p:txBody>
+          <a:bodyPr anchorCtr="0" anchor="t" bIns="0" lIns="0" spcFirstLastPara="1" rIns="0" wrap="square" tIns="0">
+            <a:spAutoFit/>
+          </a:bodyPr>
+          <a:lstStyle/>
+          <a:p>
+            <a:pPr indent="0" lvl="0" marL="0" marR="0" rtl="0" algn="l">
+              <a:lnSpc>
+                <a:spcPct val="145000"/>
+              </a:lnSpc>
+              <a:spcBef>
+                <a:spcPts val="0"/>
+              </a:spcBef>
+              <a:spcAft>
+                <a:spcPts val="0"/>
+              </a:spcAft>
+              <a:buNone/>
+            </a:pPr>
+            <a:r>
+              <a:rPr b="0" i="0" lang="en-US" sz="900" u="none" cap="none" strike="noStrike">
+                <a:solidFill>
+                  <a:srgbClr val="C5A059"/>
+                </a:solidFill>
+                <a:latin typeface="DM Sans"/>
+                <a:ea typeface="DM Sans"/>
+                <a:cs typeface="DM Sans"/>
+                <a:sym typeface="DM Sans"/>
+              </a:rPr>
+              <a:t>▪</a:t>
+            </a:r>
+            <a:endParaRPr/>
+          </a:p>
+        </p:txBody>
+      </p:sp>
+      <p:sp>
+        <p:nvSpPr>
+          <p:cNvPr id="407" name="Google Shape;407;p10"/>
+          <p:cNvSpPr txBox="1"/>
+          <p:nvPr/>
+        </p:nvSpPr>
+        <p:spPr>
+          <a:xfrm>
+            <a:off x="4505325" y="3926234"/>
+            <a:ext cx="38100" cy="161925"/>
+          </a:xfrm>
+          <a:prstGeom prst="rect">
+            <a:avLst/>
+          </a:prstGeom>
+          <a:noFill/>
+          <a:ln>
+            <a:noFill/>
+          </a:ln>
+        </p:spPr>
+        <p:txBody>
+          <a:bodyPr anchorCtr="0" anchor="t" bIns="0" lIns="0" spcFirstLastPara="1" rIns="0" wrap="square" tIns="0">
+            <a:spAutoFit/>
+          </a:bodyPr>
+          <a:lstStyle/>
+          <a:p>
+            <a:pPr indent="0" lvl="0" marL="0" marR="0" rtl="0" algn="l">
+              <a:lnSpc>
+                <a:spcPct val="145000"/>
+              </a:lnSpc>
+              <a:spcBef>
+                <a:spcPts val="0"/>
+              </a:spcBef>
+              <a:spcAft>
+                <a:spcPts val="0"/>
+              </a:spcAft>
+              <a:buNone/>
+            </a:pPr>
+            <a:r>
+              <a:rPr b="0" i="0" lang="en-US" sz="900" u="none" cap="none" strike="noStrike">
+                <a:solidFill>
+                  <a:srgbClr val="C5A059"/>
+                </a:solidFill>
+                <a:latin typeface="DM Sans"/>
+                <a:ea typeface="DM Sans"/>
+                <a:cs typeface="DM Sans"/>
+                <a:sym typeface="DM Sans"/>
+              </a:rPr>
+              <a:t>▪</a:t>
+            </a:r>
+            <a:endParaRPr/>
+          </a:p>
+        </p:txBody>
+      </p:sp>
+      <p:sp>
+        <p:nvSpPr>
+          <p:cNvPr id="408" name="Google Shape;408;p10"/>
+          <p:cNvSpPr txBox="1"/>
+          <p:nvPr/>
+        </p:nvSpPr>
+        <p:spPr>
+          <a:xfrm>
+            <a:off x="8315325" y="3011239"/>
+            <a:ext cx="38100" cy="161925"/>
+          </a:xfrm>
+          <a:prstGeom prst="rect">
+            <a:avLst/>
+          </a:prstGeom>
+          <a:noFill/>
+          <a:ln>
+            <a:noFill/>
+          </a:ln>
+        </p:spPr>
+        <p:txBody>
+          <a:bodyPr anchorCtr="0" anchor="t" bIns="0" lIns="0" spcFirstLastPara="1" rIns="0" wrap="square" tIns="0">
+            <a:spAutoFit/>
+          </a:bodyPr>
+          <a:lstStyle/>
+          <a:p>
+            <a:pPr indent="0" lvl="0" marL="0" marR="0" rtl="0" algn="l">
+              <a:lnSpc>
+                <a:spcPct val="145000"/>
+              </a:lnSpc>
+              <a:spcBef>
+                <a:spcPts val="0"/>
+              </a:spcBef>
+              <a:spcAft>
+                <a:spcPts val="0"/>
+              </a:spcAft>
+              <a:buNone/>
+            </a:pPr>
+            <a:r>
+              <a:rPr b="0" i="0" lang="en-US" sz="900" u="none" cap="none" strike="noStrike">
+                <a:solidFill>
+                  <a:srgbClr val="C5A059"/>
+                </a:solidFill>
+                <a:latin typeface="DM Sans"/>
+                <a:ea typeface="DM Sans"/>
+                <a:cs typeface="DM Sans"/>
+                <a:sym typeface="DM Sans"/>
+              </a:rPr>
+              <a:t>▪</a:t>
+            </a:r>
+            <a:endParaRPr/>
+          </a:p>
+        </p:txBody>
+      </p:sp>
+      <p:sp>
+        <p:nvSpPr>
+          <p:cNvPr id="409" name="Google Shape;409;p10"/>
+          <p:cNvSpPr txBox="1"/>
+          <p:nvPr/>
+        </p:nvSpPr>
+        <p:spPr>
+          <a:xfrm>
+            <a:off x="8315325" y="3468737"/>
+            <a:ext cx="38100" cy="161925"/>
+          </a:xfrm>
+          <a:prstGeom prst="rect">
+            <a:avLst/>
+          </a:prstGeom>
+          <a:noFill/>
+          <a:ln>
+            <a:noFill/>
+          </a:ln>
+        </p:spPr>
+        <p:txBody>
+          <a:bodyPr anchorCtr="0" anchor="t" bIns="0" lIns="0" spcFirstLastPara="1" rIns="0" wrap="square" tIns="0">
+            <a:spAutoFit/>
+          </a:bodyPr>
+          <a:lstStyle/>
+          <a:p>
+            <a:pPr indent="0" lvl="0" marL="0" marR="0" rtl="0" algn="l">
+              <a:lnSpc>
+                <a:spcPct val="145000"/>
+              </a:lnSpc>
+              <a:spcBef>
+                <a:spcPts val="0"/>
+              </a:spcBef>
+              <a:spcAft>
+                <a:spcPts val="0"/>
+              </a:spcAft>
+              <a:buNone/>
+            </a:pPr>
+            <a:r>
+              <a:rPr b="0" i="0" lang="en-US" sz="900" u="none" cap="none" strike="noStrike">
+                <a:solidFill>
+                  <a:srgbClr val="C5A059"/>
+                </a:solidFill>
+                <a:latin typeface="DM Sans"/>
+                <a:ea typeface="DM Sans"/>
+                <a:cs typeface="DM Sans"/>
+                <a:sym typeface="DM Sans"/>
+              </a:rPr>
+              <a:t>▪</a:t>
+            </a:r>
+            <a:endParaRPr/>
+          </a:p>
+        </p:txBody>
+      </p:sp>
+      <p:sp>
+        <p:nvSpPr>
           <p:cNvPr id="410" name="Google Shape;410;p10"/>
           <p:cNvSpPr txBox="1"/>
           <p:nvPr/>
         </p:nvSpPr>
         <p:spPr>
           <a:xfrm>
-            <a:off x="695325" y="3468737"/>
+            <a:off x="8315325" y="3926234"/>
             <a:ext cx="38100" cy="161925"/>
           </a:xfrm>
           <a:prstGeom prst="rect">
@@ -13407,377 +13778,6 @@
       <p:sp>
         <p:nvSpPr>
           <p:cNvPr id="411" name="Google Shape;411;p10"/>
-          <p:cNvSpPr txBox="1"/>
-          <p:nvPr/>
-        </p:nvSpPr>
-        <p:spPr>
-          <a:xfrm>
-            <a:off x="695325" y="3926234"/>
-            <a:ext cx="38100" cy="161925"/>
-          </a:xfrm>
-          <a:prstGeom prst="rect">
-            <a:avLst/>
-          </a:prstGeom>
-          <a:noFill/>
-          <a:ln>
-            <a:noFill/>
-          </a:ln>
-        </p:spPr>
-        <p:txBody>
-          <a:bodyPr anchorCtr="0" anchor="t" bIns="0" lIns="0" spcFirstLastPara="1" rIns="0" wrap="square" tIns="0">
-            <a:spAutoFit/>
-          </a:bodyPr>
-          <a:lstStyle/>
-          <a:p>
-            <a:pPr indent="0" lvl="0" marL="0" marR="0" rtl="0" algn="l">
-              <a:lnSpc>
-                <a:spcPct val="145000"/>
-              </a:lnSpc>
-              <a:spcBef>
-                <a:spcPts val="0"/>
-              </a:spcBef>
-              <a:spcAft>
-                <a:spcPts val="0"/>
-              </a:spcAft>
-              <a:buNone/>
-            </a:pPr>
-            <a:r>
-              <a:rPr b="0" i="0" lang="en-US" sz="900" u="none" cap="none" strike="noStrike">
-                <a:solidFill>
-                  <a:srgbClr val="C5A059"/>
-                </a:solidFill>
-                <a:latin typeface="DM Sans"/>
-                <a:ea typeface="DM Sans"/>
-                <a:cs typeface="DM Sans"/>
-                <a:sym typeface="DM Sans"/>
-              </a:rPr>
-              <a:t>▪</a:t>
-            </a:r>
-            <a:endParaRPr/>
-          </a:p>
-        </p:txBody>
-      </p:sp>
-      <p:sp>
-        <p:nvSpPr>
-          <p:cNvPr id="412" name="Google Shape;412;p10"/>
-          <p:cNvSpPr txBox="1"/>
-          <p:nvPr/>
-        </p:nvSpPr>
-        <p:spPr>
-          <a:xfrm>
-            <a:off x="4505325" y="3011239"/>
-            <a:ext cx="38100" cy="161925"/>
-          </a:xfrm>
-          <a:prstGeom prst="rect">
-            <a:avLst/>
-          </a:prstGeom>
-          <a:noFill/>
-          <a:ln>
-            <a:noFill/>
-          </a:ln>
-        </p:spPr>
-        <p:txBody>
-          <a:bodyPr anchorCtr="0" anchor="t" bIns="0" lIns="0" spcFirstLastPara="1" rIns="0" wrap="square" tIns="0">
-            <a:spAutoFit/>
-          </a:bodyPr>
-          <a:lstStyle/>
-          <a:p>
-            <a:pPr indent="0" lvl="0" marL="0" marR="0" rtl="0" algn="l">
-              <a:lnSpc>
-                <a:spcPct val="145000"/>
-              </a:lnSpc>
-              <a:spcBef>
-                <a:spcPts val="0"/>
-              </a:spcBef>
-              <a:spcAft>
-                <a:spcPts val="0"/>
-              </a:spcAft>
-              <a:buNone/>
-            </a:pPr>
-            <a:r>
-              <a:rPr b="0" i="0" lang="en-US" sz="900" u="none" cap="none" strike="noStrike">
-                <a:solidFill>
-                  <a:srgbClr val="C5A059"/>
-                </a:solidFill>
-                <a:latin typeface="DM Sans"/>
-                <a:ea typeface="DM Sans"/>
-                <a:cs typeface="DM Sans"/>
-                <a:sym typeface="DM Sans"/>
-              </a:rPr>
-              <a:t>▪</a:t>
-            </a:r>
-            <a:endParaRPr/>
-          </a:p>
-        </p:txBody>
-      </p:sp>
-      <p:sp>
-        <p:nvSpPr>
-          <p:cNvPr id="413" name="Google Shape;413;p10"/>
-          <p:cNvSpPr txBox="1"/>
-          <p:nvPr/>
-        </p:nvSpPr>
-        <p:spPr>
-          <a:xfrm>
-            <a:off x="4505325" y="3468737"/>
-            <a:ext cx="38100" cy="161925"/>
-          </a:xfrm>
-          <a:prstGeom prst="rect">
-            <a:avLst/>
-          </a:prstGeom>
-          <a:noFill/>
-          <a:ln>
-            <a:noFill/>
-          </a:ln>
-        </p:spPr>
-        <p:txBody>
-          <a:bodyPr anchorCtr="0" anchor="t" bIns="0" lIns="0" spcFirstLastPara="1" rIns="0" wrap="square" tIns="0">
-            <a:spAutoFit/>
-          </a:bodyPr>
-          <a:lstStyle/>
-          <a:p>
-            <a:pPr indent="0" lvl="0" marL="0" marR="0" rtl="0" algn="l">
-              <a:lnSpc>
-                <a:spcPct val="145000"/>
-              </a:lnSpc>
-              <a:spcBef>
-                <a:spcPts val="0"/>
-              </a:spcBef>
-              <a:spcAft>
-                <a:spcPts val="0"/>
-              </a:spcAft>
-              <a:buNone/>
-            </a:pPr>
-            <a:r>
-              <a:rPr b="0" i="0" lang="en-US" sz="900" u="none" cap="none" strike="noStrike">
-                <a:solidFill>
-                  <a:srgbClr val="C5A059"/>
-                </a:solidFill>
-                <a:latin typeface="DM Sans"/>
-                <a:ea typeface="DM Sans"/>
-                <a:cs typeface="DM Sans"/>
-                <a:sym typeface="DM Sans"/>
-              </a:rPr>
-              <a:t>▪</a:t>
-            </a:r>
-            <a:endParaRPr/>
-          </a:p>
-        </p:txBody>
-      </p:sp>
-      <p:sp>
-        <p:nvSpPr>
-          <p:cNvPr id="414" name="Google Shape;414;p10"/>
-          <p:cNvSpPr txBox="1"/>
-          <p:nvPr/>
-        </p:nvSpPr>
-        <p:spPr>
-          <a:xfrm>
-            <a:off x="4505325" y="3926234"/>
-            <a:ext cx="38100" cy="161925"/>
-          </a:xfrm>
-          <a:prstGeom prst="rect">
-            <a:avLst/>
-          </a:prstGeom>
-          <a:noFill/>
-          <a:ln>
-            <a:noFill/>
-          </a:ln>
-        </p:spPr>
-        <p:txBody>
-          <a:bodyPr anchorCtr="0" anchor="t" bIns="0" lIns="0" spcFirstLastPara="1" rIns="0" wrap="square" tIns="0">
-            <a:spAutoFit/>
-          </a:bodyPr>
-          <a:lstStyle/>
-          <a:p>
-            <a:pPr indent="0" lvl="0" marL="0" marR="0" rtl="0" algn="l">
-              <a:lnSpc>
-                <a:spcPct val="145000"/>
-              </a:lnSpc>
-              <a:spcBef>
-                <a:spcPts val="0"/>
-              </a:spcBef>
-              <a:spcAft>
-                <a:spcPts val="0"/>
-              </a:spcAft>
-              <a:buNone/>
-            </a:pPr>
-            <a:r>
-              <a:rPr b="0" i="0" lang="en-US" sz="900" u="none" cap="none" strike="noStrike">
-                <a:solidFill>
-                  <a:srgbClr val="C5A059"/>
-                </a:solidFill>
-                <a:latin typeface="DM Sans"/>
-                <a:ea typeface="DM Sans"/>
-                <a:cs typeface="DM Sans"/>
-                <a:sym typeface="DM Sans"/>
-              </a:rPr>
-              <a:t>▪</a:t>
-            </a:r>
-            <a:endParaRPr/>
-          </a:p>
-        </p:txBody>
-      </p:sp>
-      <p:sp>
-        <p:nvSpPr>
-          <p:cNvPr id="415" name="Google Shape;415;p10"/>
-          <p:cNvSpPr txBox="1"/>
-          <p:nvPr/>
-        </p:nvSpPr>
-        <p:spPr>
-          <a:xfrm>
-            <a:off x="8315325" y="3011239"/>
-            <a:ext cx="38100" cy="161925"/>
-          </a:xfrm>
-          <a:prstGeom prst="rect">
-            <a:avLst/>
-          </a:prstGeom>
-          <a:noFill/>
-          <a:ln>
-            <a:noFill/>
-          </a:ln>
-        </p:spPr>
-        <p:txBody>
-          <a:bodyPr anchorCtr="0" anchor="t" bIns="0" lIns="0" spcFirstLastPara="1" rIns="0" wrap="square" tIns="0">
-            <a:spAutoFit/>
-          </a:bodyPr>
-          <a:lstStyle/>
-          <a:p>
-            <a:pPr indent="0" lvl="0" marL="0" marR="0" rtl="0" algn="l">
-              <a:lnSpc>
-                <a:spcPct val="145000"/>
-              </a:lnSpc>
-              <a:spcBef>
-                <a:spcPts val="0"/>
-              </a:spcBef>
-              <a:spcAft>
-                <a:spcPts val="0"/>
-              </a:spcAft>
-              <a:buNone/>
-            </a:pPr>
-            <a:r>
-              <a:rPr b="0" i="0" lang="en-US" sz="900" u="none" cap="none" strike="noStrike">
-                <a:solidFill>
-                  <a:srgbClr val="C5A059"/>
-                </a:solidFill>
-                <a:latin typeface="DM Sans"/>
-                <a:ea typeface="DM Sans"/>
-                <a:cs typeface="DM Sans"/>
-                <a:sym typeface="DM Sans"/>
-              </a:rPr>
-              <a:t>▪</a:t>
-            </a:r>
-            <a:endParaRPr/>
-          </a:p>
-        </p:txBody>
-      </p:sp>
-      <p:sp>
-        <p:nvSpPr>
-          <p:cNvPr id="416" name="Google Shape;416;p10"/>
-          <p:cNvSpPr txBox="1"/>
-          <p:nvPr/>
-        </p:nvSpPr>
-        <p:spPr>
-          <a:xfrm>
-            <a:off x="8315325" y="3468737"/>
-            <a:ext cx="38100" cy="161925"/>
-          </a:xfrm>
-          <a:prstGeom prst="rect">
-            <a:avLst/>
-          </a:prstGeom>
-          <a:noFill/>
-          <a:ln>
-            <a:noFill/>
-          </a:ln>
-        </p:spPr>
-        <p:txBody>
-          <a:bodyPr anchorCtr="0" anchor="t" bIns="0" lIns="0" spcFirstLastPara="1" rIns="0" wrap="square" tIns="0">
-            <a:spAutoFit/>
-          </a:bodyPr>
-          <a:lstStyle/>
-          <a:p>
-            <a:pPr indent="0" lvl="0" marL="0" marR="0" rtl="0" algn="l">
-              <a:lnSpc>
-                <a:spcPct val="145000"/>
-              </a:lnSpc>
-              <a:spcBef>
-                <a:spcPts val="0"/>
-              </a:spcBef>
-              <a:spcAft>
-                <a:spcPts val="0"/>
-              </a:spcAft>
-              <a:buNone/>
-            </a:pPr>
-            <a:r>
-              <a:rPr b="0" i="0" lang="en-US" sz="900" u="none" cap="none" strike="noStrike">
-                <a:solidFill>
-                  <a:srgbClr val="C5A059"/>
-                </a:solidFill>
-                <a:latin typeface="DM Sans"/>
-                <a:ea typeface="DM Sans"/>
-                <a:cs typeface="DM Sans"/>
-                <a:sym typeface="DM Sans"/>
-              </a:rPr>
-              <a:t>▪</a:t>
-            </a:r>
-            <a:endParaRPr/>
-          </a:p>
-        </p:txBody>
-      </p:sp>
-      <p:sp>
-        <p:nvSpPr>
-          <p:cNvPr id="417" name="Google Shape;417;p10"/>
-          <p:cNvSpPr txBox="1"/>
-          <p:nvPr/>
-        </p:nvSpPr>
-        <p:spPr>
-          <a:xfrm>
-            <a:off x="8315325" y="3926234"/>
-            <a:ext cx="38100" cy="161925"/>
-          </a:xfrm>
-          <a:prstGeom prst="rect">
-            <a:avLst/>
-          </a:prstGeom>
-          <a:noFill/>
-          <a:ln>
-            <a:noFill/>
-          </a:ln>
-        </p:spPr>
-        <p:txBody>
-          <a:bodyPr anchorCtr="0" anchor="t" bIns="0" lIns="0" spcFirstLastPara="1" rIns="0" wrap="square" tIns="0">
-            <a:spAutoFit/>
-          </a:bodyPr>
-          <a:lstStyle/>
-          <a:p>
-            <a:pPr indent="0" lvl="0" marL="0" marR="0" rtl="0" algn="l">
-              <a:lnSpc>
-                <a:spcPct val="145000"/>
-              </a:lnSpc>
-              <a:spcBef>
-                <a:spcPts val="0"/>
-              </a:spcBef>
-              <a:spcAft>
-                <a:spcPts val="0"/>
-              </a:spcAft>
-              <a:buNone/>
-            </a:pPr>
-            <a:r>
-              <a:rPr b="0" i="0" lang="en-US" sz="900" u="none" cap="none" strike="noStrike">
-                <a:solidFill>
-                  <a:srgbClr val="C5A059"/>
-                </a:solidFill>
-                <a:latin typeface="DM Sans"/>
-                <a:ea typeface="DM Sans"/>
-                <a:cs typeface="DM Sans"/>
-                <a:sym typeface="DM Sans"/>
-              </a:rPr>
-              <a:t>▪</a:t>
-            </a:r>
-            <a:endParaRPr/>
-          </a:p>
-        </p:txBody>
-      </p:sp>
-      <p:sp>
-        <p:nvSpPr>
-          <p:cNvPr id="418" name="Google Shape;418;p10"/>
           <p:cNvSpPr txBox="1"/>
           <p:nvPr/>
         </p:nvSpPr>
@@ -13839,7 +13839,7 @@
       </p:sp>
       <p:sp>
         <p:nvSpPr>
-          <p:cNvPr id="419" name="Google Shape;419;p10"/>
+          <p:cNvPr id="412" name="Google Shape;412;p10"/>
           <p:cNvSpPr txBox="1"/>
           <p:nvPr/>
         </p:nvSpPr>
@@ -13903,7 +13903,7 @@
   <p:cSld>
     <p:spTree>
       <p:nvGrpSpPr>
-        <p:cNvPr id="423" name="Shape 423"/>
+        <p:cNvPr id="416" name="Shape 416"/>
         <p:cNvGrpSpPr/>
         <p:nvPr/>
       </p:nvGrpSpPr>
@@ -13917,7 +13917,7 @@
       </p:grpSpPr>
       <p:pic>
         <p:nvPicPr>
-          <p:cNvPr id="424" name="Google Shape;424;g38b9b130855_2_702"/>
+          <p:cNvPr id="417" name="Google Shape;417;g38b9b130855_2_702"/>
           <p:cNvPicPr preferRelativeResize="0"/>
           <p:nvPr/>
         </p:nvPicPr>
@@ -13944,7 +13944,7 @@
       </p:pic>
       <p:sp>
         <p:nvSpPr>
-          <p:cNvPr id="425" name="Google Shape;425;g38b9b130855_2_702"/>
+          <p:cNvPr id="418" name="Google Shape;418;g38b9b130855_2_702"/>
           <p:cNvSpPr/>
           <p:nvPr/>
         </p:nvSpPr>
@@ -13989,7 +13989,7 @@
       </p:sp>
       <p:pic>
         <p:nvPicPr>
-          <p:cNvPr id="426" name="Google Shape;426;g38b9b130855_2_702"/>
+          <p:cNvPr id="419" name="Google Shape;419;g38b9b130855_2_702"/>
           <p:cNvPicPr preferRelativeResize="0"/>
           <p:nvPr/>
         </p:nvPicPr>
@@ -14016,7 +14016,7 @@
       </p:pic>
       <p:sp>
         <p:nvSpPr>
-          <p:cNvPr id="427" name="Google Shape;427;g38b9b130855_2_702"/>
+          <p:cNvPr id="420" name="Google Shape;420;g38b9b130855_2_702"/>
           <p:cNvSpPr txBox="1"/>
           <p:nvPr/>
         </p:nvSpPr>
@@ -14074,7 +14074,7 @@
       </p:sp>
       <p:sp>
         <p:nvSpPr>
-          <p:cNvPr id="428" name="Google Shape;428;g38b9b130855_2_702"/>
+          <p:cNvPr id="421" name="Google Shape;421;g38b9b130855_2_702"/>
           <p:cNvSpPr txBox="1"/>
           <p:nvPr/>
         </p:nvSpPr>
@@ -14132,7 +14132,7 @@
       </p:sp>
       <p:sp>
         <p:nvSpPr>
-          <p:cNvPr id="429" name="Google Shape;429;g38b9b130855_2_702"/>
+          <p:cNvPr id="422" name="Google Shape;422;g38b9b130855_2_702"/>
           <p:cNvSpPr txBox="1"/>
           <p:nvPr/>
         </p:nvSpPr>
@@ -14190,7 +14190,7 @@
       </p:sp>
       <p:grpSp>
         <p:nvGrpSpPr>
-          <p:cNvPr id="430" name="Google Shape;430;g38b9b130855_2_702"/>
+          <p:cNvPr id="423" name="Google Shape;423;g38b9b130855_2_702"/>
           <p:cNvGrpSpPr/>
           <p:nvPr/>
         </p:nvGrpSpPr>
@@ -14204,7 +14204,7 @@
         </p:grpSpPr>
         <p:sp>
           <p:nvSpPr>
-            <p:cNvPr id="431" name="Google Shape;431;g38b9b130855_2_702"/>
+            <p:cNvPr id="424" name="Google Shape;424;g38b9b130855_2_702"/>
             <p:cNvSpPr/>
             <p:nvPr/>
           </p:nvSpPr>
@@ -14255,7 +14255,7 @@
         </p:sp>
         <p:sp>
           <p:nvSpPr>
-            <p:cNvPr id="432" name="Google Shape;432;g38b9b130855_2_702"/>
+            <p:cNvPr id="425" name="Google Shape;425;g38b9b130855_2_702"/>
             <p:cNvSpPr/>
             <p:nvPr/>
           </p:nvSpPr>
@@ -14300,7 +14300,7 @@
         </p:sp>
         <p:sp>
           <p:nvSpPr>
-            <p:cNvPr id="433" name="Google Shape;433;g38b9b130855_2_702"/>
+            <p:cNvPr id="426" name="Google Shape;426;g38b9b130855_2_702"/>
             <p:cNvSpPr txBox="1"/>
             <p:nvPr/>
           </p:nvSpPr>
@@ -14427,7 +14427,7 @@
       </p:grpSp>
       <p:grpSp>
         <p:nvGrpSpPr>
-          <p:cNvPr id="434" name="Google Shape;434;g38b9b130855_2_702"/>
+          <p:cNvPr id="427" name="Google Shape;427;g38b9b130855_2_702"/>
           <p:cNvGrpSpPr/>
           <p:nvPr/>
         </p:nvGrpSpPr>
@@ -14441,7 +14441,7 @@
         </p:grpSpPr>
         <p:sp>
           <p:nvSpPr>
-            <p:cNvPr id="435" name="Google Shape;435;g38b9b130855_2_702"/>
+            <p:cNvPr id="428" name="Google Shape;428;g38b9b130855_2_702"/>
             <p:cNvSpPr/>
             <p:nvPr/>
           </p:nvSpPr>
@@ -14492,7 +14492,7 @@
         </p:sp>
         <p:sp>
           <p:nvSpPr>
-            <p:cNvPr id="436" name="Google Shape;436;g38b9b130855_2_702"/>
+            <p:cNvPr id="429" name="Google Shape;429;g38b9b130855_2_702"/>
             <p:cNvSpPr/>
             <p:nvPr/>
           </p:nvSpPr>
@@ -14537,7 +14537,7 @@
         </p:sp>
         <p:sp>
           <p:nvSpPr>
-            <p:cNvPr id="437" name="Google Shape;437;g38b9b130855_2_702"/>
+            <p:cNvPr id="430" name="Google Shape;430;g38b9b130855_2_702"/>
             <p:cNvSpPr txBox="1"/>
             <p:nvPr/>
           </p:nvSpPr>
@@ -14664,7 +14664,7 @@
       </p:grpSp>
       <p:grpSp>
         <p:nvGrpSpPr>
-          <p:cNvPr id="438" name="Google Shape;438;g38b9b130855_2_702"/>
+          <p:cNvPr id="431" name="Google Shape;431;g38b9b130855_2_702"/>
           <p:cNvGrpSpPr/>
           <p:nvPr/>
         </p:nvGrpSpPr>
@@ -14678,7 +14678,7 @@
         </p:grpSpPr>
         <p:sp>
           <p:nvSpPr>
-            <p:cNvPr id="439" name="Google Shape;439;g38b9b130855_2_702"/>
+            <p:cNvPr id="432" name="Google Shape;432;g38b9b130855_2_702"/>
             <p:cNvSpPr/>
             <p:nvPr/>
           </p:nvSpPr>
@@ -14729,7 +14729,7 @@
         </p:sp>
         <p:sp>
           <p:nvSpPr>
-            <p:cNvPr id="440" name="Google Shape;440;g38b9b130855_2_702"/>
+            <p:cNvPr id="433" name="Google Shape;433;g38b9b130855_2_702"/>
             <p:cNvSpPr/>
             <p:nvPr/>
           </p:nvSpPr>
@@ -14774,7 +14774,7 @@
         </p:sp>
         <p:sp>
           <p:nvSpPr>
-            <p:cNvPr id="441" name="Google Shape;441;g38b9b130855_2_702"/>
+            <p:cNvPr id="434" name="Google Shape;434;g38b9b130855_2_702"/>
             <p:cNvSpPr txBox="1"/>
             <p:nvPr/>
           </p:nvSpPr>
@@ -16681,7 +16681,7 @@
         <p:spPr>
           <a:xfrm>
             <a:off x="8296275" y="2621160"/>
-            <a:ext cx="3219450" cy="621506"/>
+            <a:ext cx="3219600" cy="424200"/>
           </a:xfrm>
           <a:prstGeom prst="rect">
             <a:avLst/>
@@ -16719,7 +16719,7 @@
                 <a:cs typeface="DM Sans"/>
                 <a:sym typeface="DM Sans"/>
               </a:rPr>
-              <a:t>Implement JWT bearer token authorization enforcing distinct boundaries for , , and .</a:t>
+              <a:t>Implement JWT bearer token authorization enforcing distinct boundaries</a:t>
             </a:r>
             <a:endParaRPr/>
           </a:p>
@@ -17262,8 +17262,8 @@
         </p:blipFill>
         <p:spPr>
           <a:xfrm>
-            <a:off x="5553075" y="2809279"/>
-            <a:ext cx="1066800" cy="228600"/>
+            <a:off x="11325225" y="2086867"/>
+            <a:ext cx="190500" cy="152400"/>
           </a:xfrm>
           <a:prstGeom prst="rect">
             <a:avLst/>
@@ -17289,8 +17289,8 @@
         </p:blipFill>
         <p:spPr>
           <a:xfrm>
-            <a:off x="11325225" y="2086867"/>
-            <a:ext cx="190500" cy="152400"/>
+            <a:off x="3743325" y="3987998"/>
+            <a:ext cx="152400" cy="152400"/>
           </a:xfrm>
           <a:prstGeom prst="rect">
             <a:avLst/>
@@ -17316,8 +17316,8 @@
         </p:blipFill>
         <p:spPr>
           <a:xfrm>
-            <a:off x="10572750" y="2809279"/>
-            <a:ext cx="762000" cy="228600"/>
+            <a:off x="7591425" y="3987998"/>
+            <a:ext cx="114300" cy="152400"/>
           </a:xfrm>
           <a:prstGeom prst="rect">
             <a:avLst/>
@@ -17343,114 +17343,6 @@
         </p:blipFill>
         <p:spPr>
           <a:xfrm>
-            <a:off x="8296275" y="3016448"/>
-            <a:ext cx="533400" cy="228600"/>
-          </a:xfrm>
-          <a:prstGeom prst="rect">
-            <a:avLst/>
-          </a:prstGeom>
-          <a:noFill/>
-          <a:ln>
-            <a:noFill/>
-          </a:ln>
-        </p:spPr>
-      </p:pic>
-      <p:pic>
-        <p:nvPicPr>
-          <p:cNvPr descr="image.png" id="157" name="Google Shape;157;p3"/>
-          <p:cNvPicPr preferRelativeResize="0"/>
-          <p:nvPr/>
-        </p:nvPicPr>
-        <p:blipFill rotWithShape="1">
-          <a:blip r:embed="rId13">
-            <a:alphaModFix/>
-          </a:blip>
-          <a:srcRect b="0" l="0" r="0" t="0"/>
-          <a:stretch/>
-        </p:blipFill>
-        <p:spPr>
-          <a:xfrm>
-            <a:off x="9182100" y="3016448"/>
-            <a:ext cx="533400" cy="228600"/>
-          </a:xfrm>
-          <a:prstGeom prst="rect">
-            <a:avLst/>
-          </a:prstGeom>
-          <a:noFill/>
-          <a:ln>
-            <a:noFill/>
-          </a:ln>
-        </p:spPr>
-      </p:pic>
-      <p:pic>
-        <p:nvPicPr>
-          <p:cNvPr descr="image.png" id="158" name="Google Shape;158;p3"/>
-          <p:cNvPicPr preferRelativeResize="0"/>
-          <p:nvPr/>
-        </p:nvPicPr>
-        <p:blipFill rotWithShape="1">
-          <a:blip r:embed="rId14">
-            <a:alphaModFix/>
-          </a:blip>
-          <a:srcRect b="0" l="0" r="0" t="0"/>
-          <a:stretch/>
-        </p:blipFill>
-        <p:spPr>
-          <a:xfrm>
-            <a:off x="3743325" y="3987998"/>
-            <a:ext cx="152400" cy="152400"/>
-          </a:xfrm>
-          <a:prstGeom prst="rect">
-            <a:avLst/>
-          </a:prstGeom>
-          <a:noFill/>
-          <a:ln>
-            <a:noFill/>
-          </a:ln>
-        </p:spPr>
-      </p:pic>
-      <p:pic>
-        <p:nvPicPr>
-          <p:cNvPr descr="image.png" id="159" name="Google Shape;159;p3"/>
-          <p:cNvPicPr preferRelativeResize="0"/>
-          <p:nvPr/>
-        </p:nvPicPr>
-        <p:blipFill rotWithShape="1">
-          <a:blip r:embed="rId15">
-            <a:alphaModFix/>
-          </a:blip>
-          <a:srcRect b="0" l="0" r="0" t="0"/>
-          <a:stretch/>
-        </p:blipFill>
-        <p:spPr>
-          <a:xfrm>
-            <a:off x="7591425" y="3987998"/>
-            <a:ext cx="114300" cy="152400"/>
-          </a:xfrm>
-          <a:prstGeom prst="rect">
-            <a:avLst/>
-          </a:prstGeom>
-          <a:noFill/>
-          <a:ln>
-            <a:noFill/>
-          </a:ln>
-        </p:spPr>
-      </p:pic>
-      <p:pic>
-        <p:nvPicPr>
-          <p:cNvPr descr="image.png" id="160" name="Google Shape;160;p3"/>
-          <p:cNvPicPr preferRelativeResize="0"/>
-          <p:nvPr/>
-        </p:nvPicPr>
-        <p:blipFill rotWithShape="1">
-          <a:blip r:embed="rId16">
-            <a:alphaModFix/>
-          </a:blip>
-          <a:srcRect b="0" l="0" r="0" t="0"/>
-          <a:stretch/>
-        </p:blipFill>
-        <p:spPr>
-          <a:xfrm>
             <a:off x="11363325" y="3987998"/>
             <a:ext cx="152400" cy="152400"/>
           </a:xfrm>
@@ -17465,7 +17357,7 @@
       </p:pic>
       <p:sp>
         <p:nvSpPr>
-          <p:cNvPr id="161" name="Google Shape;161;p3"/>
+          <p:cNvPr id="157" name="Google Shape;157;p3"/>
           <p:cNvSpPr txBox="1"/>
           <p:nvPr/>
         </p:nvSpPr>
@@ -17527,7 +17419,7 @@
       </p:sp>
       <p:sp>
         <p:nvSpPr>
-          <p:cNvPr id="162" name="Google Shape;162;p3"/>
+          <p:cNvPr id="158" name="Google Shape;158;p3"/>
           <p:cNvSpPr txBox="1"/>
           <p:nvPr/>
         </p:nvSpPr>
@@ -17591,7 +17483,7 @@
   <p:cSld>
     <p:spTree>
       <p:nvGrpSpPr>
-        <p:cNvPr id="166" name="Shape 166"/>
+        <p:cNvPr id="162" name="Shape 162"/>
         <p:cNvGrpSpPr/>
         <p:nvPr/>
       </p:nvGrpSpPr>
@@ -17605,7 +17497,7 @@
       </p:grpSpPr>
       <p:pic>
         <p:nvPicPr>
-          <p:cNvPr descr="image.png" id="167" name="Google Shape;167;p4"/>
+          <p:cNvPr descr="image.png" id="163" name="Google Shape;163;p4"/>
           <p:cNvPicPr preferRelativeResize="0"/>
           <p:nvPr/>
         </p:nvPicPr>
@@ -17632,7 +17524,7 @@
       </p:pic>
       <p:pic>
         <p:nvPicPr>
-          <p:cNvPr descr="image.png" id="168" name="Google Shape;168;p4"/>
+          <p:cNvPr descr="image.png" id="164" name="Google Shape;164;p4"/>
           <p:cNvPicPr preferRelativeResize="0"/>
           <p:nvPr/>
         </p:nvPicPr>
@@ -17659,7 +17551,7 @@
       </p:pic>
       <p:sp>
         <p:nvSpPr>
-          <p:cNvPr id="169" name="Google Shape;169;p4"/>
+          <p:cNvPr id="165" name="Google Shape;165;p4"/>
           <p:cNvSpPr txBox="1"/>
           <p:nvPr/>
         </p:nvSpPr>
@@ -17709,7 +17601,7 @@
       </p:sp>
       <p:sp>
         <p:nvSpPr>
-          <p:cNvPr id="170" name="Google Shape;170;p4"/>
+          <p:cNvPr id="166" name="Google Shape;166;p4"/>
           <p:cNvSpPr txBox="1"/>
           <p:nvPr/>
         </p:nvSpPr>
@@ -17759,7 +17651,7 @@
       </p:sp>
       <p:sp>
         <p:nvSpPr>
-          <p:cNvPr id="171" name="Google Shape;171;p4"/>
+          <p:cNvPr id="167" name="Google Shape;167;p4"/>
           <p:cNvSpPr txBox="1"/>
           <p:nvPr/>
         </p:nvSpPr>
@@ -17833,7 +17725,7 @@
       </p:sp>
       <p:grpSp>
         <p:nvGrpSpPr>
-          <p:cNvPr id="172" name="Google Shape;172;p4"/>
+          <p:cNvPr id="168" name="Google Shape;168;p4"/>
           <p:cNvGrpSpPr/>
           <p:nvPr/>
         </p:nvGrpSpPr>
@@ -17847,7 +17739,7 @@
         </p:grpSpPr>
         <p:sp>
           <p:nvSpPr>
-            <p:cNvPr id="173" name="Google Shape;173;p4"/>
+            <p:cNvPr id="169" name="Google Shape;169;p4"/>
             <p:cNvSpPr/>
             <p:nvPr/>
           </p:nvSpPr>
@@ -17892,7 +17784,7 @@
         </p:sp>
         <p:sp>
           <p:nvSpPr>
-            <p:cNvPr id="174" name="Google Shape;174;p4"/>
+            <p:cNvPr id="170" name="Google Shape;170;p4"/>
             <p:cNvSpPr/>
             <p:nvPr/>
           </p:nvSpPr>
@@ -17943,7 +17835,7 @@
         </p:sp>
         <p:sp>
           <p:nvSpPr>
-            <p:cNvPr id="175" name="Google Shape;175;p4"/>
+            <p:cNvPr id="171" name="Google Shape;171;p4"/>
             <p:cNvSpPr txBox="1"/>
             <p:nvPr/>
           </p:nvSpPr>
@@ -18013,7 +17905,7 @@
         </p:sp>
         <p:cxnSp>
           <p:nvCxnSpPr>
-            <p:cNvPr id="176" name="Google Shape;176;p4"/>
+            <p:cNvPr id="172" name="Google Shape;172;p4"/>
             <p:cNvCxnSpPr/>
             <p:nvPr/>
           </p:nvCxnSpPr>
@@ -18041,7 +17933,7 @@
         </p:cxnSp>
         <p:grpSp>
           <p:nvGrpSpPr>
-            <p:cNvPr id="177" name="Google Shape;177;p4"/>
+            <p:cNvPr id="173" name="Google Shape;173;p4"/>
             <p:cNvGrpSpPr/>
             <p:nvPr/>
           </p:nvGrpSpPr>
@@ -18055,7 +17947,7 @@
           </p:grpSpPr>
           <p:sp>
             <p:nvSpPr>
-              <p:cNvPr id="178" name="Google Shape;178;p4"/>
+              <p:cNvPr id="174" name="Google Shape;174;p4"/>
               <p:cNvSpPr/>
               <p:nvPr/>
             </p:nvSpPr>
@@ -18106,7 +17998,7 @@
           </p:sp>
           <p:sp>
             <p:nvSpPr>
-              <p:cNvPr id="179" name="Google Shape;179;p4"/>
+              <p:cNvPr id="175" name="Google Shape;175;p4"/>
               <p:cNvSpPr txBox="1"/>
               <p:nvPr/>
             </p:nvSpPr>
@@ -18197,7 +18089,7 @@
         </p:grpSp>
         <p:grpSp>
           <p:nvGrpSpPr>
-            <p:cNvPr id="180" name="Google Shape;180;p4"/>
+            <p:cNvPr id="176" name="Google Shape;176;p4"/>
             <p:cNvGrpSpPr/>
             <p:nvPr/>
           </p:nvGrpSpPr>
@@ -18211,7 +18103,7 @@
           </p:grpSpPr>
           <p:sp>
             <p:nvSpPr>
-              <p:cNvPr id="181" name="Google Shape;181;p4"/>
+              <p:cNvPr id="177" name="Google Shape;177;p4"/>
               <p:cNvSpPr/>
               <p:nvPr/>
             </p:nvSpPr>
@@ -18262,7 +18154,7 @@
           </p:sp>
           <p:sp>
             <p:nvSpPr>
-              <p:cNvPr id="182" name="Google Shape;182;p4"/>
+              <p:cNvPr id="178" name="Google Shape;178;p4"/>
               <p:cNvSpPr txBox="1"/>
               <p:nvPr/>
             </p:nvSpPr>
@@ -18376,7 +18268,7 @@
         </p:grpSp>
         <p:grpSp>
           <p:nvGrpSpPr>
-            <p:cNvPr id="183" name="Google Shape;183;p4"/>
+            <p:cNvPr id="179" name="Google Shape;179;p4"/>
             <p:cNvGrpSpPr/>
             <p:nvPr/>
           </p:nvGrpSpPr>
@@ -18390,7 +18282,7 @@
           </p:grpSpPr>
           <p:sp>
             <p:nvSpPr>
-              <p:cNvPr id="184" name="Google Shape;184;p4"/>
+              <p:cNvPr id="180" name="Google Shape;180;p4"/>
               <p:cNvSpPr/>
               <p:nvPr/>
             </p:nvSpPr>
@@ -18441,7 +18333,7 @@
           </p:sp>
           <p:sp>
             <p:nvSpPr>
-              <p:cNvPr id="185" name="Google Shape;185;p4"/>
+              <p:cNvPr id="181" name="Google Shape;181;p4"/>
               <p:cNvSpPr txBox="1"/>
               <p:nvPr/>
             </p:nvSpPr>
@@ -18556,7 +18448,7 @@
         </p:grpSp>
         <p:grpSp>
           <p:nvGrpSpPr>
-            <p:cNvPr id="186" name="Google Shape;186;p4"/>
+            <p:cNvPr id="182" name="Google Shape;182;p4"/>
             <p:cNvGrpSpPr/>
             <p:nvPr/>
           </p:nvGrpSpPr>
@@ -18570,7 +18462,7 @@
           </p:grpSpPr>
           <p:sp>
             <p:nvSpPr>
-              <p:cNvPr id="187" name="Google Shape;187;p4"/>
+              <p:cNvPr id="183" name="Google Shape;183;p4"/>
               <p:cNvSpPr/>
               <p:nvPr/>
             </p:nvSpPr>
@@ -18621,7 +18513,7 @@
           </p:sp>
           <p:sp>
             <p:nvSpPr>
-              <p:cNvPr id="188" name="Google Shape;188;p4"/>
+              <p:cNvPr id="184" name="Google Shape;184;p4"/>
               <p:cNvSpPr txBox="1"/>
               <p:nvPr/>
             </p:nvSpPr>
@@ -18735,7 +18627,7 @@
         </p:grpSp>
         <p:grpSp>
           <p:nvGrpSpPr>
-            <p:cNvPr id="189" name="Google Shape;189;p4"/>
+            <p:cNvPr id="185" name="Google Shape;185;p4"/>
             <p:cNvGrpSpPr/>
             <p:nvPr/>
           </p:nvGrpSpPr>
@@ -18749,7 +18641,7 @@
           </p:grpSpPr>
           <p:sp>
             <p:nvSpPr>
-              <p:cNvPr id="190" name="Google Shape;190;p4"/>
+              <p:cNvPr id="186" name="Google Shape;186;p4"/>
               <p:cNvSpPr/>
               <p:nvPr/>
             </p:nvSpPr>
@@ -18800,7 +18692,7 @@
           </p:sp>
           <p:sp>
             <p:nvSpPr>
-              <p:cNvPr id="191" name="Google Shape;191;p4"/>
+              <p:cNvPr id="187" name="Google Shape;187;p4"/>
               <p:cNvSpPr txBox="1"/>
               <p:nvPr/>
             </p:nvSpPr>
@@ -18915,7 +18807,7 @@
         </p:grpSp>
         <p:grpSp>
           <p:nvGrpSpPr>
-            <p:cNvPr id="192" name="Google Shape;192;p4"/>
+            <p:cNvPr id="188" name="Google Shape;188;p4"/>
             <p:cNvGrpSpPr/>
             <p:nvPr/>
           </p:nvGrpSpPr>
@@ -18929,7 +18821,7 @@
           </p:grpSpPr>
           <p:sp>
             <p:nvSpPr>
-              <p:cNvPr id="193" name="Google Shape;193;p4"/>
+              <p:cNvPr id="189" name="Google Shape;189;p4"/>
               <p:cNvSpPr/>
               <p:nvPr/>
             </p:nvSpPr>
@@ -18980,7 +18872,7 @@
           </p:sp>
           <p:sp>
             <p:nvSpPr>
-              <p:cNvPr id="194" name="Google Shape;194;p4"/>
+              <p:cNvPr id="190" name="Google Shape;190;p4"/>
               <p:cNvSpPr txBox="1"/>
               <p:nvPr/>
             </p:nvSpPr>
@@ -19095,7 +18987,7 @@
         </p:grpSp>
         <p:sp>
           <p:nvSpPr>
-            <p:cNvPr id="195" name="Google Shape;195;p4"/>
+            <p:cNvPr id="191" name="Google Shape;191;p4"/>
             <p:cNvSpPr/>
             <p:nvPr/>
           </p:nvSpPr>
@@ -19165,7 +19057,7 @@
         </p:sp>
         <p:sp>
           <p:nvSpPr>
-            <p:cNvPr id="196" name="Google Shape;196;p4"/>
+            <p:cNvPr id="192" name="Google Shape;192;p4"/>
             <p:cNvSpPr/>
             <p:nvPr/>
           </p:nvSpPr>
@@ -19235,7 +19127,7 @@
         </p:sp>
         <p:sp>
           <p:nvSpPr>
-            <p:cNvPr id="197" name="Google Shape;197;p4"/>
+            <p:cNvPr id="193" name="Google Shape;193;p4"/>
             <p:cNvSpPr txBox="1"/>
             <p:nvPr/>
           </p:nvSpPr>
@@ -19438,7 +19330,7 @@
       </p:grpSp>
       <p:sp>
         <p:nvSpPr>
-          <p:cNvPr id="198" name="Google Shape;198;p4"/>
+          <p:cNvPr id="194" name="Google Shape;194;p4"/>
           <p:cNvSpPr txBox="1"/>
           <p:nvPr/>
         </p:nvSpPr>
@@ -19488,7 +19380,7 @@
       </p:sp>
       <p:sp>
         <p:nvSpPr>
-          <p:cNvPr id="199" name="Google Shape;199;p4"/>
+          <p:cNvPr id="195" name="Google Shape;195;p4"/>
           <p:cNvSpPr txBox="1"/>
           <p:nvPr/>
         </p:nvSpPr>
@@ -19552,7 +19444,7 @@
   <p:cSld>
     <p:spTree>
       <p:nvGrpSpPr>
-        <p:cNvPr id="203" name="Shape 203"/>
+        <p:cNvPr id="199" name="Shape 199"/>
         <p:cNvGrpSpPr/>
         <p:nvPr/>
       </p:nvGrpSpPr>
@@ -19566,7 +19458,7 @@
       </p:grpSpPr>
       <p:pic>
         <p:nvPicPr>
-          <p:cNvPr descr="image.png" id="204" name="Google Shape;204;p5"/>
+          <p:cNvPr descr="image.png" id="200" name="Google Shape;200;p5"/>
           <p:cNvPicPr preferRelativeResize="0"/>
           <p:nvPr/>
         </p:nvPicPr>
@@ -19593,7 +19485,7 @@
       </p:pic>
       <p:pic>
         <p:nvPicPr>
-          <p:cNvPr descr="image.png" id="205" name="Google Shape;205;p5"/>
+          <p:cNvPr descr="image.png" id="201" name="Google Shape;201;p5"/>
           <p:cNvPicPr preferRelativeResize="0"/>
           <p:nvPr/>
         </p:nvPicPr>
@@ -19620,7 +19512,7 @@
       </p:pic>
       <p:pic>
         <p:nvPicPr>
-          <p:cNvPr descr="image.png" id="206" name="Google Shape;206;p5"/>
+          <p:cNvPr descr="image.png" id="202" name="Google Shape;202;p5"/>
           <p:cNvPicPr preferRelativeResize="0"/>
           <p:nvPr/>
         </p:nvPicPr>
@@ -19647,7 +19539,7 @@
       </p:pic>
       <p:pic>
         <p:nvPicPr>
-          <p:cNvPr descr="image.png" id="207" name="Google Shape;207;p5"/>
+          <p:cNvPr descr="image.png" id="203" name="Google Shape;203;p5"/>
           <p:cNvPicPr preferRelativeResize="0"/>
           <p:nvPr/>
         </p:nvPicPr>
@@ -19674,7 +19566,7 @@
       </p:pic>
       <p:sp>
         <p:nvSpPr>
-          <p:cNvPr id="208" name="Google Shape;208;p5"/>
+          <p:cNvPr id="204" name="Google Shape;204;p5"/>
           <p:cNvSpPr txBox="1"/>
           <p:nvPr/>
         </p:nvSpPr>
@@ -19724,7 +19616,7 @@
       </p:sp>
       <p:sp>
         <p:nvSpPr>
-          <p:cNvPr id="209" name="Google Shape;209;p5"/>
+          <p:cNvPr id="205" name="Google Shape;205;p5"/>
           <p:cNvSpPr txBox="1"/>
           <p:nvPr/>
         </p:nvSpPr>
@@ -19774,7 +19666,7 @@
       </p:sp>
       <p:sp>
         <p:nvSpPr>
-          <p:cNvPr id="210" name="Google Shape;210;p5"/>
+          <p:cNvPr id="206" name="Google Shape;206;p5"/>
           <p:cNvSpPr txBox="1"/>
           <p:nvPr/>
         </p:nvSpPr>
@@ -19818,7 +19710,7 @@
       </p:sp>
       <p:sp>
         <p:nvSpPr>
-          <p:cNvPr id="211" name="Google Shape;211;p5"/>
+          <p:cNvPr id="207" name="Google Shape;207;p5"/>
           <p:cNvSpPr txBox="1"/>
           <p:nvPr/>
         </p:nvSpPr>
@@ -19868,7 +19760,7 @@
       </p:sp>
       <p:sp>
         <p:nvSpPr>
-          <p:cNvPr id="212" name="Google Shape;212;p5"/>
+          <p:cNvPr id="208" name="Google Shape;208;p5"/>
           <p:cNvSpPr txBox="1"/>
           <p:nvPr/>
         </p:nvSpPr>
@@ -19921,7 +19813,7 @@
       </p:sp>
       <p:sp>
         <p:nvSpPr>
-          <p:cNvPr id="213" name="Google Shape;213;p5"/>
+          <p:cNvPr id="209" name="Google Shape;209;p5"/>
           <p:cNvSpPr txBox="1"/>
           <p:nvPr/>
         </p:nvSpPr>
@@ -19971,7 +19863,7 @@
       </p:sp>
       <p:sp>
         <p:nvSpPr>
-          <p:cNvPr id="214" name="Google Shape;214;p5"/>
+          <p:cNvPr id="210" name="Google Shape;210;p5"/>
           <p:cNvSpPr txBox="1"/>
           <p:nvPr/>
         </p:nvSpPr>
@@ -20024,7 +19916,7 @@
       </p:sp>
       <p:sp>
         <p:nvSpPr>
-          <p:cNvPr id="215" name="Google Shape;215;p5"/>
+          <p:cNvPr id="211" name="Google Shape;211;p5"/>
           <p:cNvSpPr txBox="1"/>
           <p:nvPr/>
         </p:nvSpPr>
@@ -20086,7 +19978,7 @@
       </p:sp>
       <p:sp>
         <p:nvSpPr>
-          <p:cNvPr id="216" name="Google Shape;216;p5"/>
+          <p:cNvPr id="212" name="Google Shape;212;p5"/>
           <p:cNvSpPr txBox="1"/>
           <p:nvPr/>
         </p:nvSpPr>
@@ -20151,7 +20043,7 @@
       </p:sp>
       <p:pic>
         <p:nvPicPr>
-          <p:cNvPr id="217" name="Google Shape;217;p5"/>
+          <p:cNvPr id="213" name="Google Shape;213;p5"/>
           <p:cNvPicPr preferRelativeResize="0"/>
           <p:nvPr/>
         </p:nvPicPr>
@@ -20190,7 +20082,7 @@
   <p:cSld>
     <p:spTree>
       <p:nvGrpSpPr>
-        <p:cNvPr id="221" name="Shape 221"/>
+        <p:cNvPr id="217" name="Shape 217"/>
         <p:cNvGrpSpPr/>
         <p:nvPr/>
       </p:nvGrpSpPr>
@@ -20204,7 +20096,7 @@
       </p:grpSpPr>
       <p:pic>
         <p:nvPicPr>
-          <p:cNvPr descr="image.png" id="222" name="Google Shape;222;p6"/>
+          <p:cNvPr descr="image.png" id="218" name="Google Shape;218;p6"/>
           <p:cNvPicPr preferRelativeResize="0"/>
           <p:nvPr/>
         </p:nvPicPr>
@@ -20231,7 +20123,7 @@
       </p:pic>
       <p:pic>
         <p:nvPicPr>
-          <p:cNvPr descr="image.png" id="223" name="Google Shape;223;p6"/>
+          <p:cNvPr descr="image.png" id="219" name="Google Shape;219;p6"/>
           <p:cNvPicPr preferRelativeResize="0"/>
           <p:nvPr/>
         </p:nvPicPr>
@@ -20258,7 +20150,7 @@
       </p:pic>
       <p:pic>
         <p:nvPicPr>
-          <p:cNvPr descr="image.png" id="224" name="Google Shape;224;p6"/>
+          <p:cNvPr descr="image.png" id="220" name="Google Shape;220;p6"/>
           <p:cNvPicPr preferRelativeResize="0"/>
           <p:nvPr/>
         </p:nvPicPr>
@@ -20285,7 +20177,7 @@
       </p:pic>
       <p:pic>
         <p:nvPicPr>
-          <p:cNvPr descr="image.png" id="225" name="Google Shape;225;p6"/>
+          <p:cNvPr descr="image.png" id="221" name="Google Shape;221;p6"/>
           <p:cNvPicPr preferRelativeResize="0"/>
           <p:nvPr/>
         </p:nvPicPr>
@@ -20312,7 +20204,7 @@
       </p:pic>
       <p:pic>
         <p:nvPicPr>
-          <p:cNvPr descr="image.png" id="226" name="Google Shape;226;p6"/>
+          <p:cNvPr descr="image.png" id="222" name="Google Shape;222;p6"/>
           <p:cNvPicPr preferRelativeResize="0"/>
           <p:nvPr/>
         </p:nvPicPr>
@@ -20339,7 +20231,7 @@
       </p:pic>
       <p:pic>
         <p:nvPicPr>
-          <p:cNvPr descr="image.png" id="227" name="Google Shape;227;p6"/>
+          <p:cNvPr descr="image.png" id="223" name="Google Shape;223;p6"/>
           <p:cNvPicPr preferRelativeResize="0"/>
           <p:nvPr/>
         </p:nvPicPr>
@@ -20366,7 +20258,7 @@
       </p:pic>
       <p:pic>
         <p:nvPicPr>
-          <p:cNvPr descr="image.png" id="228" name="Google Shape;228;p6"/>
+          <p:cNvPr descr="image.png" id="224" name="Google Shape;224;p6"/>
           <p:cNvPicPr preferRelativeResize="0"/>
           <p:nvPr/>
         </p:nvPicPr>
@@ -20393,7 +20285,7 @@
       </p:pic>
       <p:pic>
         <p:nvPicPr>
-          <p:cNvPr descr="image.png" id="229" name="Google Shape;229;p6"/>
+          <p:cNvPr descr="image.png" id="225" name="Google Shape;225;p6"/>
           <p:cNvPicPr preferRelativeResize="0"/>
           <p:nvPr/>
         </p:nvPicPr>
@@ -20420,7 +20312,7 @@
       </p:pic>
       <p:sp>
         <p:nvSpPr>
-          <p:cNvPr id="230" name="Google Shape;230;p6"/>
+          <p:cNvPr id="226" name="Google Shape;226;p6"/>
           <p:cNvSpPr txBox="1"/>
           <p:nvPr/>
         </p:nvSpPr>
@@ -20470,7 +20362,7 @@
       </p:sp>
       <p:sp>
         <p:nvSpPr>
-          <p:cNvPr id="231" name="Google Shape;231;p6"/>
+          <p:cNvPr id="227" name="Google Shape;227;p6"/>
           <p:cNvSpPr txBox="1"/>
           <p:nvPr/>
         </p:nvSpPr>
@@ -20520,7 +20412,7 @@
       </p:sp>
       <p:sp>
         <p:nvSpPr>
-          <p:cNvPr id="232" name="Google Shape;232;p6"/>
+          <p:cNvPr id="228" name="Google Shape;228;p6"/>
           <p:cNvSpPr txBox="1"/>
           <p:nvPr/>
         </p:nvSpPr>
@@ -20570,7 +20462,7 @@
       </p:sp>
       <p:sp>
         <p:nvSpPr>
-          <p:cNvPr id="233" name="Google Shape;233;p6"/>
+          <p:cNvPr id="229" name="Google Shape;229;p6"/>
           <p:cNvSpPr txBox="1"/>
           <p:nvPr/>
         </p:nvSpPr>
@@ -20623,14 +20515,14 @@
       </p:sp>
       <p:sp>
         <p:nvSpPr>
-          <p:cNvPr id="234" name="Google Shape;234;p6"/>
+          <p:cNvPr id="230" name="Google Shape;230;p6"/>
           <p:cNvSpPr txBox="1"/>
           <p:nvPr/>
         </p:nvSpPr>
         <p:spPr>
           <a:xfrm>
             <a:off x="704850" y="2749153"/>
-            <a:ext cx="3190875" cy="600521"/>
+            <a:ext cx="3190800" cy="409800"/>
           </a:xfrm>
           <a:prstGeom prst="rect">
             <a:avLst/>
@@ -20668,7 +20560,7 @@
                 <a:cs typeface="DM Sans"/>
                 <a:sym typeface="DM Sans"/>
               </a:rPr>
-              <a:t>Registration with bcrypt-hashed passwords and structured KYC capture (, , address, income).</a:t>
+              <a:t>Registration with bcrypt-hashed passwords and structured KYC capture (address, income).</a:t>
             </a:r>
             <a:endParaRPr/>
           </a:p>
@@ -20676,7 +20568,7 @@
       </p:sp>
       <p:sp>
         <p:nvSpPr>
-          <p:cNvPr id="235" name="Google Shape;235;p6"/>
+          <p:cNvPr id="231" name="Google Shape;231;p6"/>
           <p:cNvSpPr txBox="1"/>
           <p:nvPr/>
         </p:nvSpPr>
@@ -20726,7 +20618,7 @@
       </p:sp>
       <p:sp>
         <p:nvSpPr>
-          <p:cNvPr id="236" name="Google Shape;236;p6"/>
+          <p:cNvPr id="232" name="Google Shape;232;p6"/>
           <p:cNvSpPr txBox="1"/>
           <p:nvPr/>
         </p:nvSpPr>
@@ -20779,7 +20671,7 @@
       </p:sp>
       <p:sp>
         <p:nvSpPr>
-          <p:cNvPr id="237" name="Google Shape;237;p6"/>
+          <p:cNvPr id="233" name="Google Shape;233;p6"/>
           <p:cNvSpPr txBox="1"/>
           <p:nvPr/>
         </p:nvSpPr>
@@ -20832,7 +20724,7 @@
       </p:sp>
       <p:sp>
         <p:nvSpPr>
-          <p:cNvPr id="238" name="Google Shape;238;p6"/>
+          <p:cNvPr id="234" name="Google Shape;234;p6"/>
           <p:cNvSpPr txBox="1"/>
           <p:nvPr/>
         </p:nvSpPr>
@@ -20882,7 +20774,7 @@
       </p:sp>
       <p:sp>
         <p:nvSpPr>
-          <p:cNvPr id="239" name="Google Shape;239;p6"/>
+          <p:cNvPr id="235" name="Google Shape;235;p6"/>
           <p:cNvSpPr txBox="1"/>
           <p:nvPr/>
         </p:nvSpPr>
@@ -20935,7 +20827,7 @@
       </p:sp>
       <p:sp>
         <p:nvSpPr>
-          <p:cNvPr id="240" name="Google Shape;240;p6"/>
+          <p:cNvPr id="236" name="Google Shape;236;p6"/>
           <p:cNvSpPr txBox="1"/>
           <p:nvPr/>
         </p:nvSpPr>
@@ -20988,7 +20880,7 @@
       </p:sp>
       <p:sp>
         <p:nvSpPr>
-          <p:cNvPr id="241" name="Google Shape;241;p6"/>
+          <p:cNvPr id="237" name="Google Shape;237;p6"/>
           <p:cNvSpPr txBox="1"/>
           <p:nvPr/>
         </p:nvSpPr>
@@ -21038,7 +20930,7 @@
       </p:sp>
       <p:sp>
         <p:nvSpPr>
-          <p:cNvPr id="242" name="Google Shape;242;p6"/>
+          <p:cNvPr id="238" name="Google Shape;238;p6"/>
           <p:cNvSpPr txBox="1"/>
           <p:nvPr/>
         </p:nvSpPr>
@@ -21091,7 +20983,7 @@
       </p:sp>
       <p:sp>
         <p:nvSpPr>
-          <p:cNvPr id="243" name="Google Shape;243;p6"/>
+          <p:cNvPr id="239" name="Google Shape;239;p6"/>
           <p:cNvSpPr txBox="1"/>
           <p:nvPr/>
         </p:nvSpPr>
@@ -21144,7 +21036,7 @@
       </p:sp>
       <p:sp>
         <p:nvSpPr>
-          <p:cNvPr id="244" name="Google Shape;244;p6"/>
+          <p:cNvPr id="240" name="Google Shape;240;p6"/>
           <p:cNvSpPr txBox="1"/>
           <p:nvPr/>
         </p:nvSpPr>
@@ -21194,7 +21086,7 @@
       </p:sp>
       <p:sp>
         <p:nvSpPr>
-          <p:cNvPr id="245" name="Google Shape;245;p6"/>
+          <p:cNvPr id="241" name="Google Shape;241;p6"/>
           <p:cNvSpPr txBox="1"/>
           <p:nvPr/>
         </p:nvSpPr>
@@ -21247,7 +21139,7 @@
       </p:sp>
       <p:sp>
         <p:nvSpPr>
-          <p:cNvPr id="246" name="Google Shape;246;p6"/>
+          <p:cNvPr id="242" name="Google Shape;242;p6"/>
           <p:cNvSpPr txBox="1"/>
           <p:nvPr/>
         </p:nvSpPr>
@@ -21300,7 +21192,7 @@
       </p:sp>
       <p:sp>
         <p:nvSpPr>
-          <p:cNvPr id="247" name="Google Shape;247;p6"/>
+          <p:cNvPr id="243" name="Google Shape;243;p6"/>
           <p:cNvSpPr txBox="1"/>
           <p:nvPr/>
         </p:nvSpPr>
@@ -21350,7 +21242,7 @@
       </p:sp>
       <p:sp>
         <p:nvSpPr>
-          <p:cNvPr id="248" name="Google Shape;248;p6"/>
+          <p:cNvPr id="244" name="Google Shape;244;p6"/>
           <p:cNvSpPr txBox="1"/>
           <p:nvPr/>
         </p:nvSpPr>
@@ -21403,7 +21295,7 @@
       </p:sp>
       <p:sp>
         <p:nvSpPr>
-          <p:cNvPr id="249" name="Google Shape;249;p6"/>
+          <p:cNvPr id="245" name="Google Shape;245;p6"/>
           <p:cNvSpPr txBox="1"/>
           <p:nvPr/>
         </p:nvSpPr>
@@ -21456,7 +21348,7 @@
       </p:sp>
       <p:pic>
         <p:nvPicPr>
-          <p:cNvPr descr="image.png" id="250" name="Google Shape;250;p6"/>
+          <p:cNvPr descr="image.png" id="246" name="Google Shape;246;p6"/>
           <p:cNvPicPr preferRelativeResize="0"/>
           <p:nvPr/>
         </p:nvPicPr>
@@ -21483,7 +21375,7 @@
       </p:pic>
       <p:pic>
         <p:nvPicPr>
-          <p:cNvPr descr="image.png" id="251" name="Google Shape;251;p6"/>
+          <p:cNvPr descr="image.png" id="247" name="Google Shape;247;p6"/>
           <p:cNvPicPr preferRelativeResize="0"/>
           <p:nvPr/>
         </p:nvPicPr>
@@ -21496,8 +21388,8 @@
         </p:blipFill>
         <p:spPr>
           <a:xfrm>
-            <a:off x="2266950" y="2930276"/>
-            <a:ext cx="838200" cy="228600"/>
+            <a:off x="7553325" y="2231082"/>
+            <a:ext cx="152400" cy="152400"/>
           </a:xfrm>
           <a:prstGeom prst="rect">
             <a:avLst/>
@@ -21510,7 +21402,7 @@
       </p:pic>
       <p:pic>
         <p:nvPicPr>
-          <p:cNvPr descr="image.png" id="252" name="Google Shape;252;p6"/>
+          <p:cNvPr descr="image.png" id="248" name="Google Shape;248;p6"/>
           <p:cNvPicPr preferRelativeResize="0"/>
           <p:nvPr/>
         </p:nvPicPr>
@@ -21523,8 +21415,8 @@
         </p:blipFill>
         <p:spPr>
           <a:xfrm>
-            <a:off x="704850" y="3130450"/>
-            <a:ext cx="1143000" cy="228600"/>
+            <a:off x="11363325" y="2131069"/>
+            <a:ext cx="152400" cy="152400"/>
           </a:xfrm>
           <a:prstGeom prst="rect">
             <a:avLst/>
@@ -21537,7 +21429,7 @@
       </p:pic>
       <p:pic>
         <p:nvPicPr>
-          <p:cNvPr descr="image.png" id="253" name="Google Shape;253;p6"/>
+          <p:cNvPr descr="image.png" id="249" name="Google Shape;249;p6"/>
           <p:cNvPicPr preferRelativeResize="0"/>
           <p:nvPr/>
         </p:nvPicPr>
@@ -21550,8 +21442,8 @@
         </p:blipFill>
         <p:spPr>
           <a:xfrm>
-            <a:off x="7553325" y="2231082"/>
-            <a:ext cx="152400" cy="152400"/>
+            <a:off x="3705225" y="4064198"/>
+            <a:ext cx="190500" cy="152400"/>
           </a:xfrm>
           <a:prstGeom prst="rect">
             <a:avLst/>
@@ -21564,7 +21456,7 @@
       </p:pic>
       <p:pic>
         <p:nvPicPr>
-          <p:cNvPr descr="image.png" id="254" name="Google Shape;254;p6"/>
+          <p:cNvPr descr="image.png" id="250" name="Google Shape;250;p6"/>
           <p:cNvPicPr preferRelativeResize="0"/>
           <p:nvPr/>
         </p:nvPicPr>
@@ -21577,8 +21469,8 @@
         </p:blipFill>
         <p:spPr>
           <a:xfrm>
-            <a:off x="11363325" y="2131069"/>
-            <a:ext cx="152400" cy="152400"/>
+            <a:off x="7591425" y="4164359"/>
+            <a:ext cx="114300" cy="152400"/>
           </a:xfrm>
           <a:prstGeom prst="rect">
             <a:avLst/>
@@ -21591,7 +21483,7 @@
       </p:pic>
       <p:pic>
         <p:nvPicPr>
-          <p:cNvPr descr="image.png" id="255" name="Google Shape;255;p6"/>
+          <p:cNvPr descr="image.png" id="251" name="Google Shape;251;p6"/>
           <p:cNvPicPr preferRelativeResize="0"/>
           <p:nvPr/>
         </p:nvPicPr>
@@ -21604,8 +21496,8 @@
         </p:blipFill>
         <p:spPr>
           <a:xfrm>
-            <a:off x="8324850" y="2830264"/>
-            <a:ext cx="2286000" cy="428773"/>
+            <a:off x="5048250" y="4663380"/>
+            <a:ext cx="1066800" cy="228600"/>
           </a:xfrm>
           <a:prstGeom prst="rect">
             <a:avLst/>
@@ -21618,7 +21510,7 @@
       </p:pic>
       <p:pic>
         <p:nvPicPr>
-          <p:cNvPr descr="image.png" id="256" name="Google Shape;256;p6"/>
+          <p:cNvPr descr="image.png" id="252" name="Google Shape;252;p6"/>
           <p:cNvPicPr preferRelativeResize="0"/>
           <p:nvPr/>
         </p:nvPicPr>
@@ -21631,87 +21523,6 @@
         </p:blipFill>
         <p:spPr>
           <a:xfrm>
-            <a:off x="3705225" y="4064198"/>
-            <a:ext cx="190500" cy="152400"/>
-          </a:xfrm>
-          <a:prstGeom prst="rect">
-            <a:avLst/>
-          </a:prstGeom>
-          <a:noFill/>
-          <a:ln>
-            <a:noFill/>
-          </a:ln>
-        </p:spPr>
-      </p:pic>
-      <p:pic>
-        <p:nvPicPr>
-          <p:cNvPr descr="image.png" id="257" name="Google Shape;257;p6"/>
-          <p:cNvPicPr preferRelativeResize="0"/>
-          <p:nvPr/>
-        </p:nvPicPr>
-        <p:blipFill rotWithShape="1">
-          <a:blip r:embed="rId16">
-            <a:alphaModFix/>
-          </a:blip>
-          <a:srcRect b="0" l="0" r="0" t="0"/>
-          <a:stretch/>
-        </p:blipFill>
-        <p:spPr>
-          <a:xfrm>
-            <a:off x="7591425" y="4164359"/>
-            <a:ext cx="114300" cy="152400"/>
-          </a:xfrm>
-          <a:prstGeom prst="rect">
-            <a:avLst/>
-          </a:prstGeom>
-          <a:noFill/>
-          <a:ln>
-            <a:noFill/>
-          </a:ln>
-        </p:spPr>
-      </p:pic>
-      <p:pic>
-        <p:nvPicPr>
-          <p:cNvPr descr="image.png" id="258" name="Google Shape;258;p6"/>
-          <p:cNvPicPr preferRelativeResize="0"/>
-          <p:nvPr/>
-        </p:nvPicPr>
-        <p:blipFill rotWithShape="1">
-          <a:blip r:embed="rId17">
-            <a:alphaModFix/>
-          </a:blip>
-          <a:srcRect b="0" l="0" r="0" t="0"/>
-          <a:stretch/>
-        </p:blipFill>
-        <p:spPr>
-          <a:xfrm>
-            <a:off x="5048250" y="4663380"/>
-            <a:ext cx="1066800" cy="228600"/>
-          </a:xfrm>
-          <a:prstGeom prst="rect">
-            <a:avLst/>
-          </a:prstGeom>
-          <a:noFill/>
-          <a:ln>
-            <a:noFill/>
-          </a:ln>
-        </p:spPr>
-      </p:pic>
-      <p:pic>
-        <p:nvPicPr>
-          <p:cNvPr descr="image.png" id="259" name="Google Shape;259;p6"/>
-          <p:cNvPicPr preferRelativeResize="0"/>
-          <p:nvPr/>
-        </p:nvPicPr>
-        <p:blipFill rotWithShape="1">
-          <a:blip r:embed="rId18">
-            <a:alphaModFix/>
-          </a:blip>
-          <a:srcRect b="0" l="0" r="0" t="0"/>
-          <a:stretch/>
-        </p:blipFill>
-        <p:spPr>
-          <a:xfrm>
             <a:off x="11325225" y="4064198"/>
             <a:ext cx="190500" cy="152400"/>
           </a:xfrm>
@@ -21726,7 +21537,7 @@
       </p:pic>
       <p:sp>
         <p:nvSpPr>
-          <p:cNvPr id="260" name="Google Shape;260;p6"/>
+          <p:cNvPr id="253" name="Google Shape;253;p6"/>
           <p:cNvSpPr txBox="1"/>
           <p:nvPr/>
         </p:nvSpPr>
@@ -21788,7 +21599,7 @@
       </p:sp>
       <p:sp>
         <p:nvSpPr>
-          <p:cNvPr id="261" name="Google Shape;261;p6"/>
+          <p:cNvPr id="254" name="Google Shape;254;p6"/>
           <p:cNvSpPr txBox="1"/>
           <p:nvPr/>
         </p:nvSpPr>
@@ -21852,7 +21663,7 @@
   <p:cSld>
     <p:spTree>
       <p:nvGrpSpPr>
-        <p:cNvPr id="265" name="Shape 265"/>
+        <p:cNvPr id="258" name="Shape 258"/>
         <p:cNvGrpSpPr/>
         <p:nvPr/>
       </p:nvGrpSpPr>
@@ -21866,7 +21677,7 @@
       </p:grpSpPr>
       <p:pic>
         <p:nvPicPr>
-          <p:cNvPr descr="image.png" id="266" name="Google Shape;266;p7"/>
+          <p:cNvPr descr="image.png" id="259" name="Google Shape;259;p7"/>
           <p:cNvPicPr preferRelativeResize="0"/>
           <p:nvPr/>
         </p:nvPicPr>
@@ -21893,7 +21704,7 @@
       </p:pic>
       <p:pic>
         <p:nvPicPr>
-          <p:cNvPr descr="image.png" id="267" name="Google Shape;267;p7"/>
+          <p:cNvPr descr="image.png" id="260" name="Google Shape;260;p7"/>
           <p:cNvPicPr preferRelativeResize="0"/>
           <p:nvPr/>
         </p:nvPicPr>
@@ -21920,7 +21731,7 @@
       </p:pic>
       <p:pic>
         <p:nvPicPr>
-          <p:cNvPr descr="image.png" id="268" name="Google Shape;268;p7"/>
+          <p:cNvPr descr="image.png" id="261" name="Google Shape;261;p7"/>
           <p:cNvPicPr preferRelativeResize="0"/>
           <p:nvPr/>
         </p:nvPicPr>
@@ -21947,7 +21758,7 @@
       </p:pic>
       <p:pic>
         <p:nvPicPr>
-          <p:cNvPr descr="image.png" id="269" name="Google Shape;269;p7"/>
+          <p:cNvPr descr="image.png" id="262" name="Google Shape;262;p7"/>
           <p:cNvPicPr preferRelativeResize="0"/>
           <p:nvPr/>
         </p:nvPicPr>
@@ -21974,7 +21785,7 @@
       </p:pic>
       <p:pic>
         <p:nvPicPr>
-          <p:cNvPr descr="image.png" id="270" name="Google Shape;270;p7"/>
+          <p:cNvPr descr="image.png" id="263" name="Google Shape;263;p7"/>
           <p:cNvPicPr preferRelativeResize="0"/>
           <p:nvPr/>
         </p:nvPicPr>
@@ -22001,7 +21812,7 @@
       </p:pic>
       <p:pic>
         <p:nvPicPr>
-          <p:cNvPr descr="image.png" id="271" name="Google Shape;271;p7"/>
+          <p:cNvPr descr="image.png" id="264" name="Google Shape;264;p7"/>
           <p:cNvPicPr preferRelativeResize="0"/>
           <p:nvPr/>
         </p:nvPicPr>
@@ -22028,7 +21839,7 @@
       </p:pic>
       <p:pic>
         <p:nvPicPr>
-          <p:cNvPr descr="image.png" id="272" name="Google Shape;272;p7"/>
+          <p:cNvPr descr="image.png" id="265" name="Google Shape;265;p7"/>
           <p:cNvPicPr preferRelativeResize="0"/>
           <p:nvPr/>
         </p:nvPicPr>
@@ -22055,7 +21866,7 @@
       </p:pic>
       <p:pic>
         <p:nvPicPr>
-          <p:cNvPr descr="image.png" id="273" name="Google Shape;273;p7"/>
+          <p:cNvPr descr="image.png" id="266" name="Google Shape;266;p7"/>
           <p:cNvPicPr preferRelativeResize="0"/>
           <p:nvPr/>
         </p:nvPicPr>
@@ -22082,7 +21893,7 @@
       </p:pic>
       <p:sp>
         <p:nvSpPr>
-          <p:cNvPr id="274" name="Google Shape;274;p7"/>
+          <p:cNvPr id="267" name="Google Shape;267;p7"/>
           <p:cNvSpPr txBox="1"/>
           <p:nvPr/>
         </p:nvSpPr>
@@ -22132,7 +21943,7 @@
       </p:sp>
       <p:sp>
         <p:nvSpPr>
-          <p:cNvPr id="275" name="Google Shape;275;p7"/>
+          <p:cNvPr id="268" name="Google Shape;268;p7"/>
           <p:cNvSpPr txBox="1"/>
           <p:nvPr/>
         </p:nvSpPr>
@@ -22182,7 +21993,7 @@
       </p:sp>
       <p:sp>
         <p:nvSpPr>
-          <p:cNvPr id="276" name="Google Shape;276;p7"/>
+          <p:cNvPr id="269" name="Google Shape;269;p7"/>
           <p:cNvSpPr txBox="1"/>
           <p:nvPr/>
         </p:nvSpPr>
@@ -22232,7 +22043,7 @@
       </p:sp>
       <p:sp>
         <p:nvSpPr>
-          <p:cNvPr id="277" name="Google Shape;277;p7"/>
+          <p:cNvPr id="270" name="Google Shape;270;p7"/>
           <p:cNvSpPr txBox="1"/>
           <p:nvPr/>
         </p:nvSpPr>
@@ -22285,7 +22096,7 @@
       </p:sp>
       <p:sp>
         <p:nvSpPr>
-          <p:cNvPr id="278" name="Google Shape;278;p7"/>
+          <p:cNvPr id="271" name="Google Shape;271;p7"/>
           <p:cNvSpPr txBox="1"/>
           <p:nvPr/>
         </p:nvSpPr>
@@ -22338,7 +22149,7 @@
       </p:sp>
       <p:sp>
         <p:nvSpPr>
-          <p:cNvPr id="279" name="Google Shape;279;p7"/>
+          <p:cNvPr id="272" name="Google Shape;272;p7"/>
           <p:cNvSpPr txBox="1"/>
           <p:nvPr/>
         </p:nvSpPr>
@@ -22388,7 +22199,7 @@
       </p:sp>
       <p:sp>
         <p:nvSpPr>
-          <p:cNvPr id="280" name="Google Shape;280;p7"/>
+          <p:cNvPr id="273" name="Google Shape;273;p7"/>
           <p:cNvSpPr txBox="1"/>
           <p:nvPr/>
         </p:nvSpPr>
@@ -22441,7 +22252,7 @@
       </p:sp>
       <p:sp>
         <p:nvSpPr>
-          <p:cNvPr id="281" name="Google Shape;281;p7"/>
+          <p:cNvPr id="274" name="Google Shape;274;p7"/>
           <p:cNvSpPr txBox="1"/>
           <p:nvPr/>
         </p:nvSpPr>
@@ -22494,7 +22305,7 @@
       </p:sp>
       <p:sp>
         <p:nvSpPr>
-          <p:cNvPr id="282" name="Google Shape;282;p7"/>
+          <p:cNvPr id="275" name="Google Shape;275;p7"/>
           <p:cNvSpPr txBox="1"/>
           <p:nvPr/>
         </p:nvSpPr>
@@ -22544,7 +22355,7 @@
       </p:sp>
       <p:sp>
         <p:nvSpPr>
-          <p:cNvPr id="283" name="Google Shape;283;p7"/>
+          <p:cNvPr id="276" name="Google Shape;276;p7"/>
           <p:cNvSpPr txBox="1"/>
           <p:nvPr/>
         </p:nvSpPr>
@@ -22597,7 +22408,7 @@
       </p:sp>
       <p:sp>
         <p:nvSpPr>
-          <p:cNvPr id="284" name="Google Shape;284;p7"/>
+          <p:cNvPr id="277" name="Google Shape;277;p7"/>
           <p:cNvSpPr txBox="1"/>
           <p:nvPr/>
         </p:nvSpPr>
@@ -22650,7 +22461,7 @@
       </p:sp>
       <p:sp>
         <p:nvSpPr>
-          <p:cNvPr id="285" name="Google Shape;285;p7"/>
+          <p:cNvPr id="278" name="Google Shape;278;p7"/>
           <p:cNvSpPr txBox="1"/>
           <p:nvPr/>
         </p:nvSpPr>
@@ -22700,7 +22511,7 @@
       </p:sp>
       <p:sp>
         <p:nvSpPr>
-          <p:cNvPr id="286" name="Google Shape;286;p7"/>
+          <p:cNvPr id="279" name="Google Shape;279;p7"/>
           <p:cNvSpPr txBox="1"/>
           <p:nvPr/>
         </p:nvSpPr>
@@ -22753,7 +22564,7 @@
       </p:sp>
       <p:sp>
         <p:nvSpPr>
-          <p:cNvPr id="287" name="Google Shape;287;p7"/>
+          <p:cNvPr id="280" name="Google Shape;280;p7"/>
           <p:cNvSpPr txBox="1"/>
           <p:nvPr/>
         </p:nvSpPr>
@@ -22806,7 +22617,7 @@
       </p:sp>
       <p:sp>
         <p:nvSpPr>
-          <p:cNvPr id="288" name="Google Shape;288;p7"/>
+          <p:cNvPr id="281" name="Google Shape;281;p7"/>
           <p:cNvSpPr txBox="1"/>
           <p:nvPr/>
         </p:nvSpPr>
@@ -22856,7 +22667,7 @@
       </p:sp>
       <p:sp>
         <p:nvSpPr>
-          <p:cNvPr id="289" name="Google Shape;289;p7"/>
+          <p:cNvPr id="282" name="Google Shape;282;p7"/>
           <p:cNvSpPr txBox="1"/>
           <p:nvPr/>
         </p:nvSpPr>
@@ -22909,7 +22720,7 @@
       </p:sp>
       <p:sp>
         <p:nvSpPr>
-          <p:cNvPr id="290" name="Google Shape;290;p7"/>
+          <p:cNvPr id="283" name="Google Shape;283;p7"/>
           <p:cNvSpPr txBox="1"/>
           <p:nvPr/>
         </p:nvSpPr>
@@ -22962,7 +22773,7 @@
       </p:sp>
       <p:sp>
         <p:nvSpPr>
-          <p:cNvPr id="291" name="Google Shape;291;p7"/>
+          <p:cNvPr id="284" name="Google Shape;284;p7"/>
           <p:cNvSpPr txBox="1"/>
           <p:nvPr/>
         </p:nvSpPr>
@@ -23012,7 +22823,7 @@
       </p:sp>
       <p:sp>
         <p:nvSpPr>
-          <p:cNvPr id="292" name="Google Shape;292;p7"/>
+          <p:cNvPr id="285" name="Google Shape;285;p7"/>
           <p:cNvSpPr txBox="1"/>
           <p:nvPr/>
         </p:nvSpPr>
@@ -23065,7 +22876,7 @@
       </p:sp>
       <p:sp>
         <p:nvSpPr>
-          <p:cNvPr id="293" name="Google Shape;293;p7"/>
+          <p:cNvPr id="286" name="Google Shape;286;p7"/>
           <p:cNvSpPr txBox="1"/>
           <p:nvPr/>
         </p:nvSpPr>
@@ -23118,7 +22929,7 @@
       </p:sp>
       <p:pic>
         <p:nvPicPr>
-          <p:cNvPr descr="image.png" id="294" name="Google Shape;294;p7"/>
+          <p:cNvPr descr="image.png" id="287" name="Google Shape;287;p7"/>
           <p:cNvPicPr preferRelativeResize="0"/>
           <p:nvPr/>
         </p:nvPicPr>
@@ -23145,7 +22956,7 @@
       </p:pic>
       <p:pic>
         <p:nvPicPr>
-          <p:cNvPr descr="image.png" id="295" name="Google Shape;295;p7"/>
+          <p:cNvPr descr="image.png" id="288" name="Google Shape;288;p7"/>
           <p:cNvPicPr preferRelativeResize="0"/>
           <p:nvPr/>
         </p:nvPicPr>
@@ -23172,7 +22983,7 @@
       </p:pic>
       <p:pic>
         <p:nvPicPr>
-          <p:cNvPr descr="image.png" id="296" name="Google Shape;296;p7"/>
+          <p:cNvPr descr="image.png" id="289" name="Google Shape;289;p7"/>
           <p:cNvPicPr preferRelativeResize="0"/>
           <p:nvPr/>
         </p:nvPicPr>
@@ -23199,7 +23010,7 @@
       </p:pic>
       <p:pic>
         <p:nvPicPr>
-          <p:cNvPr descr="image.png" id="297" name="Google Shape;297;p7"/>
+          <p:cNvPr descr="image.png" id="290" name="Google Shape;290;p7"/>
           <p:cNvPicPr preferRelativeResize="0"/>
           <p:nvPr/>
         </p:nvPicPr>
@@ -23226,7 +23037,7 @@
       </p:pic>
       <p:pic>
         <p:nvPicPr>
-          <p:cNvPr descr="image.png" id="298" name="Google Shape;298;p7"/>
+          <p:cNvPr descr="image.png" id="291" name="Google Shape;291;p7"/>
           <p:cNvPicPr preferRelativeResize="0"/>
           <p:nvPr/>
         </p:nvPicPr>
@@ -23253,7 +23064,7 @@
       </p:pic>
       <p:pic>
         <p:nvPicPr>
-          <p:cNvPr descr="image.png" id="299" name="Google Shape;299;p7"/>
+          <p:cNvPr descr="image.png" id="292" name="Google Shape;292;p7"/>
           <p:cNvPicPr preferRelativeResize="0"/>
           <p:nvPr/>
         </p:nvPicPr>
@@ -23266,8 +23077,8 @@
         </p:blipFill>
         <p:spPr>
           <a:xfrm>
-            <a:off x="9153525" y="2930276"/>
-            <a:ext cx="609600" cy="228600"/>
+            <a:off x="8934450" y="2930275"/>
+            <a:ext cx="876650" cy="228600"/>
           </a:xfrm>
           <a:prstGeom prst="rect">
             <a:avLst/>
@@ -23280,7 +23091,7 @@
       </p:pic>
       <p:pic>
         <p:nvPicPr>
-          <p:cNvPr descr="image.png" id="300" name="Google Shape;300;p7"/>
+          <p:cNvPr descr="image.png" id="293" name="Google Shape;293;p7"/>
           <p:cNvPicPr preferRelativeResize="0"/>
           <p:nvPr/>
         </p:nvPicPr>
@@ -23307,7 +23118,7 @@
       </p:pic>
       <p:pic>
         <p:nvPicPr>
-          <p:cNvPr descr="image.png" id="301" name="Google Shape;301;p7"/>
+          <p:cNvPr descr="image.png" id="294" name="Google Shape;294;p7"/>
           <p:cNvPicPr preferRelativeResize="0"/>
           <p:nvPr/>
         </p:nvPicPr>
@@ -23334,7 +23145,7 @@
       </p:pic>
       <p:pic>
         <p:nvPicPr>
-          <p:cNvPr descr="image.png" id="302" name="Google Shape;302;p7"/>
+          <p:cNvPr descr="image.png" id="295" name="Google Shape;295;p7"/>
           <p:cNvPicPr preferRelativeResize="0"/>
           <p:nvPr/>
         </p:nvPicPr>
@@ -23361,7 +23172,7 @@
       </p:pic>
       <p:pic>
         <p:nvPicPr>
-          <p:cNvPr descr="image.png" id="303" name="Google Shape;303;p7"/>
+          <p:cNvPr descr="image.png" id="296" name="Google Shape;296;p7"/>
           <p:cNvPicPr preferRelativeResize="0"/>
           <p:nvPr/>
         </p:nvPicPr>
@@ -23388,7 +23199,7 @@
       </p:pic>
       <p:pic>
         <p:nvPicPr>
-          <p:cNvPr descr="image.png" id="304" name="Google Shape;304;p7"/>
+          <p:cNvPr descr="image.png" id="297" name="Google Shape;297;p7"/>
           <p:cNvPicPr preferRelativeResize="0"/>
           <p:nvPr/>
         </p:nvPicPr>
@@ -23415,7 +23226,7 @@
       </p:pic>
       <p:pic>
         <p:nvPicPr>
-          <p:cNvPr descr="image.png" id="305" name="Google Shape;305;p7"/>
+          <p:cNvPr descr="image.png" id="298" name="Google Shape;298;p7"/>
           <p:cNvPicPr preferRelativeResize="0"/>
           <p:nvPr/>
         </p:nvPicPr>
@@ -23442,7 +23253,7 @@
       </p:pic>
       <p:sp>
         <p:nvSpPr>
-          <p:cNvPr id="306" name="Google Shape;306;p7"/>
+          <p:cNvPr id="299" name="Google Shape;299;p7"/>
           <p:cNvSpPr txBox="1"/>
           <p:nvPr/>
         </p:nvSpPr>
@@ -23504,7 +23315,7 @@
       </p:sp>
       <p:sp>
         <p:nvSpPr>
-          <p:cNvPr id="307" name="Google Shape;307;p7"/>
+          <p:cNvPr id="300" name="Google Shape;300;p7"/>
           <p:cNvSpPr txBox="1"/>
           <p:nvPr/>
         </p:nvSpPr>
@@ -23568,7 +23379,7 @@
   <p:cSld>
     <p:spTree>
       <p:nvGrpSpPr>
-        <p:cNvPr id="311" name="Shape 311"/>
+        <p:cNvPr id="304" name="Shape 304"/>
         <p:cNvGrpSpPr/>
         <p:nvPr/>
       </p:nvGrpSpPr>
@@ -23582,7 +23393,7 @@
       </p:grpSpPr>
       <p:pic>
         <p:nvPicPr>
-          <p:cNvPr descr="image.png" id="312" name="Google Shape;312;p8"/>
+          <p:cNvPr descr="image.png" id="305" name="Google Shape;305;p8"/>
           <p:cNvPicPr preferRelativeResize="0"/>
           <p:nvPr/>
         </p:nvPicPr>
@@ -23609,7 +23420,7 @@
       </p:pic>
       <p:pic>
         <p:nvPicPr>
-          <p:cNvPr descr="image.png" id="313" name="Google Shape;313;p8"/>
+          <p:cNvPr descr="image.png" id="306" name="Google Shape;306;p8"/>
           <p:cNvPicPr preferRelativeResize="0"/>
           <p:nvPr/>
         </p:nvPicPr>
@@ -23636,7 +23447,7 @@
       </p:pic>
       <p:pic>
         <p:nvPicPr>
-          <p:cNvPr descr="image.png" id="314" name="Google Shape;314;p8"/>
+          <p:cNvPr descr="image.png" id="307" name="Google Shape;307;p8"/>
           <p:cNvPicPr preferRelativeResize="0"/>
           <p:nvPr/>
         </p:nvPicPr>
@@ -23663,7 +23474,7 @@
       </p:pic>
       <p:pic>
         <p:nvPicPr>
-          <p:cNvPr descr="image.png" id="315" name="Google Shape;315;p8"/>
+          <p:cNvPr descr="image.png" id="308" name="Google Shape;308;p8"/>
           <p:cNvPicPr preferRelativeResize="0"/>
           <p:nvPr/>
         </p:nvPicPr>
@@ -23690,7 +23501,7 @@
       </p:pic>
       <p:pic>
         <p:nvPicPr>
-          <p:cNvPr descr="image.png" id="316" name="Google Shape;316;p8"/>
+          <p:cNvPr descr="image.png" id="309" name="Google Shape;309;p8"/>
           <p:cNvPicPr preferRelativeResize="0"/>
           <p:nvPr/>
         </p:nvPicPr>
@@ -23717,7 +23528,7 @@
       </p:pic>
       <p:pic>
         <p:nvPicPr>
-          <p:cNvPr descr="image.png" id="317" name="Google Shape;317;p8"/>
+          <p:cNvPr descr="image.png" id="310" name="Google Shape;310;p8"/>
           <p:cNvPicPr preferRelativeResize="0"/>
           <p:nvPr/>
         </p:nvPicPr>
@@ -23744,7 +23555,7 @@
       </p:pic>
       <p:pic>
         <p:nvPicPr>
-          <p:cNvPr descr="image.png" id="318" name="Google Shape;318;p8"/>
+          <p:cNvPr descr="image.png" id="311" name="Google Shape;311;p8"/>
           <p:cNvPicPr preferRelativeResize="0"/>
           <p:nvPr/>
         </p:nvPicPr>
@@ -23771,7 +23582,7 @@
       </p:pic>
       <p:pic>
         <p:nvPicPr>
-          <p:cNvPr descr="image.png" id="319" name="Google Shape;319;p8"/>
+          <p:cNvPr descr="image.png" id="312" name="Google Shape;312;p8"/>
           <p:cNvPicPr preferRelativeResize="0"/>
           <p:nvPr/>
         </p:nvPicPr>
@@ -23798,7 +23609,7 @@
       </p:pic>
       <p:sp>
         <p:nvSpPr>
-          <p:cNvPr id="320" name="Google Shape;320;p8"/>
+          <p:cNvPr id="313" name="Google Shape;313;p8"/>
           <p:cNvSpPr txBox="1"/>
           <p:nvPr/>
         </p:nvSpPr>
@@ -23848,7 +23659,7 @@
       </p:sp>
       <p:sp>
         <p:nvSpPr>
-          <p:cNvPr id="321" name="Google Shape;321;p8"/>
+          <p:cNvPr id="314" name="Google Shape;314;p8"/>
           <p:cNvSpPr txBox="1"/>
           <p:nvPr/>
         </p:nvSpPr>
@@ -23898,7 +23709,7 @@
       </p:sp>
       <p:sp>
         <p:nvSpPr>
-          <p:cNvPr id="322" name="Google Shape;322;p8"/>
+          <p:cNvPr id="315" name="Google Shape;315;p8"/>
           <p:cNvSpPr txBox="1"/>
           <p:nvPr/>
         </p:nvSpPr>
@@ -23948,7 +23759,7 @@
       </p:sp>
       <p:sp>
         <p:nvSpPr>
-          <p:cNvPr id="323" name="Google Shape;323;p8"/>
+          <p:cNvPr id="316" name="Google Shape;316;p8"/>
           <p:cNvSpPr txBox="1"/>
           <p:nvPr/>
         </p:nvSpPr>
@@ -24001,7 +23812,7 @@
       </p:sp>
       <p:sp>
         <p:nvSpPr>
-          <p:cNvPr id="324" name="Google Shape;324;p8"/>
+          <p:cNvPr id="317" name="Google Shape;317;p8"/>
           <p:cNvSpPr txBox="1"/>
           <p:nvPr/>
         </p:nvSpPr>
@@ -24051,7 +23862,7 @@
       </p:sp>
       <p:sp>
         <p:nvSpPr>
-          <p:cNvPr id="325" name="Google Shape;325;p8"/>
+          <p:cNvPr id="318" name="Google Shape;318;p8"/>
           <p:cNvSpPr txBox="1"/>
           <p:nvPr/>
         </p:nvSpPr>
@@ -24104,7 +23915,7 @@
       </p:sp>
       <p:sp>
         <p:nvSpPr>
-          <p:cNvPr id="326" name="Google Shape;326;p8"/>
+          <p:cNvPr id="319" name="Google Shape;319;p8"/>
           <p:cNvSpPr txBox="1"/>
           <p:nvPr/>
         </p:nvSpPr>
@@ -24154,7 +23965,7 @@
       </p:sp>
       <p:sp>
         <p:nvSpPr>
-          <p:cNvPr id="327" name="Google Shape;327;p8"/>
+          <p:cNvPr id="320" name="Google Shape;320;p8"/>
           <p:cNvSpPr txBox="1"/>
           <p:nvPr/>
         </p:nvSpPr>
@@ -24207,7 +24018,7 @@
       </p:sp>
       <p:sp>
         <p:nvSpPr>
-          <p:cNvPr id="328" name="Google Shape;328;p8"/>
+          <p:cNvPr id="321" name="Google Shape;321;p8"/>
           <p:cNvSpPr txBox="1"/>
           <p:nvPr/>
         </p:nvSpPr>
@@ -24257,7 +24068,7 @@
       </p:sp>
       <p:sp>
         <p:nvSpPr>
-          <p:cNvPr id="329" name="Google Shape;329;p8"/>
+          <p:cNvPr id="322" name="Google Shape;322;p8"/>
           <p:cNvSpPr txBox="1"/>
           <p:nvPr/>
         </p:nvSpPr>
@@ -24310,7 +24121,7 @@
       </p:sp>
       <p:sp>
         <p:nvSpPr>
-          <p:cNvPr id="330" name="Google Shape;330;p8"/>
+          <p:cNvPr id="323" name="Google Shape;323;p8"/>
           <p:cNvSpPr txBox="1"/>
           <p:nvPr/>
         </p:nvSpPr>
@@ -24360,7 +24171,7 @@
       </p:sp>
       <p:sp>
         <p:nvSpPr>
-          <p:cNvPr id="331" name="Google Shape;331;p8"/>
+          <p:cNvPr id="324" name="Google Shape;324;p8"/>
           <p:cNvSpPr txBox="1"/>
           <p:nvPr/>
         </p:nvSpPr>
@@ -24413,7 +24224,7 @@
       </p:sp>
       <p:sp>
         <p:nvSpPr>
-          <p:cNvPr id="332" name="Google Shape;332;p8"/>
+          <p:cNvPr id="325" name="Google Shape;325;p8"/>
           <p:cNvSpPr txBox="1"/>
           <p:nvPr/>
         </p:nvSpPr>
@@ -24463,7 +24274,7 @@
       </p:sp>
       <p:sp>
         <p:nvSpPr>
-          <p:cNvPr id="333" name="Google Shape;333;p8"/>
+          <p:cNvPr id="326" name="Google Shape;326;p8"/>
           <p:cNvSpPr txBox="1"/>
           <p:nvPr/>
         </p:nvSpPr>
@@ -24516,7 +24327,7 @@
       </p:sp>
       <p:pic>
         <p:nvPicPr>
-          <p:cNvPr descr="image.png" id="334" name="Google Shape;334;p8"/>
+          <p:cNvPr descr="image.png" id="327" name="Google Shape;327;p8"/>
           <p:cNvPicPr preferRelativeResize="0"/>
           <p:nvPr/>
         </p:nvPicPr>
@@ -24543,7 +24354,7 @@
       </p:pic>
       <p:pic>
         <p:nvPicPr>
-          <p:cNvPr descr="image.png" id="335" name="Google Shape;335;p8"/>
+          <p:cNvPr descr="image.png" id="328" name="Google Shape;328;p8"/>
           <p:cNvPicPr preferRelativeResize="0"/>
           <p:nvPr/>
         </p:nvPicPr>
@@ -24570,7 +24381,7 @@
       </p:pic>
       <p:pic>
         <p:nvPicPr>
-          <p:cNvPr descr="image.png" id="336" name="Google Shape;336;p8"/>
+          <p:cNvPr descr="image.png" id="329" name="Google Shape;329;p8"/>
           <p:cNvPicPr preferRelativeResize="0"/>
           <p:nvPr/>
         </p:nvPicPr>
@@ -24597,7 +24408,7 @@
       </p:pic>
       <p:pic>
         <p:nvPicPr>
-          <p:cNvPr descr="image.png" id="337" name="Google Shape;337;p8"/>
+          <p:cNvPr descr="image.png" id="330" name="Google Shape;330;p8"/>
           <p:cNvPicPr preferRelativeResize="0"/>
           <p:nvPr/>
         </p:nvPicPr>
@@ -24624,7 +24435,7 @@
       </p:pic>
       <p:pic>
         <p:nvPicPr>
-          <p:cNvPr descr="image.png" id="338" name="Google Shape;338;p8"/>
+          <p:cNvPr descr="image.png" id="331" name="Google Shape;331;p8"/>
           <p:cNvPicPr preferRelativeResize="0"/>
           <p:nvPr/>
         </p:nvPicPr>
@@ -24651,7 +24462,7 @@
       </p:pic>
       <p:pic>
         <p:nvPicPr>
-          <p:cNvPr descr="image.png" id="339" name="Google Shape;339;p8"/>
+          <p:cNvPr descr="image.png" id="332" name="Google Shape;332;p8"/>
           <p:cNvPicPr preferRelativeResize="0"/>
           <p:nvPr/>
         </p:nvPicPr>
@@ -24678,7 +24489,7 @@
       </p:pic>
       <p:sp>
         <p:nvSpPr>
-          <p:cNvPr id="340" name="Google Shape;340;p8"/>
+          <p:cNvPr id="333" name="Google Shape;333;p8"/>
           <p:cNvSpPr txBox="1"/>
           <p:nvPr/>
         </p:nvSpPr>
@@ -24740,7 +24551,7 @@
       </p:sp>
       <p:sp>
         <p:nvSpPr>
-          <p:cNvPr id="341" name="Google Shape;341;p8"/>
+          <p:cNvPr id="334" name="Google Shape;334;p8"/>
           <p:cNvSpPr txBox="1"/>
           <p:nvPr/>
         </p:nvSpPr>
@@ -24804,7 +24615,7 @@
   <p:cSld>
     <p:spTree>
       <p:nvGrpSpPr>
-        <p:cNvPr id="345" name="Shape 345"/>
+        <p:cNvPr id="338" name="Shape 338"/>
         <p:cNvGrpSpPr/>
         <p:nvPr/>
       </p:nvGrpSpPr>
@@ -24818,7 +24629,7 @@
       </p:grpSpPr>
       <p:pic>
         <p:nvPicPr>
-          <p:cNvPr descr="image.png" id="346" name="Google Shape;346;p9"/>
+          <p:cNvPr descr="image.png" id="339" name="Google Shape;339;p9"/>
           <p:cNvPicPr preferRelativeResize="0"/>
           <p:nvPr/>
         </p:nvPicPr>
@@ -24845,7 +24656,7 @@
       </p:pic>
       <p:pic>
         <p:nvPicPr>
-          <p:cNvPr descr="image.png" id="347" name="Google Shape;347;p9"/>
+          <p:cNvPr descr="image.png" id="340" name="Google Shape;340;p9"/>
           <p:cNvPicPr preferRelativeResize="0"/>
           <p:nvPr/>
         </p:nvPicPr>
@@ -24872,7 +24683,7 @@
       </p:pic>
       <p:pic>
         <p:nvPicPr>
-          <p:cNvPr descr="image.png" id="348" name="Google Shape;348;p9"/>
+          <p:cNvPr descr="image.png" id="341" name="Google Shape;341;p9"/>
           <p:cNvPicPr preferRelativeResize="0"/>
           <p:nvPr/>
         </p:nvPicPr>
@@ -24899,7 +24710,7 @@
       </p:pic>
       <p:sp>
         <p:nvSpPr>
-          <p:cNvPr id="349" name="Google Shape;349;p9"/>
+          <p:cNvPr id="342" name="Google Shape;342;p9"/>
           <p:cNvSpPr txBox="1"/>
           <p:nvPr/>
         </p:nvSpPr>
@@ -24949,7 +24760,7 @@
       </p:sp>
       <p:sp>
         <p:nvSpPr>
-          <p:cNvPr id="350" name="Google Shape;350;p9"/>
+          <p:cNvPr id="343" name="Google Shape;343;p9"/>
           <p:cNvSpPr txBox="1"/>
           <p:nvPr/>
         </p:nvSpPr>
@@ -24999,7 +24810,7 @@
       </p:sp>
       <p:graphicFrame>
         <p:nvGraphicFramePr>
-          <p:cNvPr id="351" name="Google Shape;351;p9"/>
+          <p:cNvPr id="344" name="Google Shape;344;p9"/>
           <p:cNvGraphicFramePr/>
           <p:nvPr/>
         </p:nvGraphicFramePr>
@@ -25012,7 +24823,7 @@
             <a:tbl>
               <a:tblPr bandRow="1" firstRow="1">
                 <a:noFill/>
-                <a:tableStyleId>{6A77BD74-AA04-4C57-9890-40E591AC0B61}</a:tableStyleId>
+                <a:tableStyleId>{7CBCFFB1-AF99-435F-BF80-E7414F75585F}</a:tableStyleId>
               </a:tblPr>
               <a:tblGrid>
                 <a:gridCol w="2692900"/>
@@ -26898,20 +26709,377 @@
       </p:graphicFrame>
       <p:sp>
         <p:nvSpPr>
+          <p:cNvPr id="345" name="Google Shape;345;p9"/>
+          <p:cNvSpPr/>
+          <p:nvPr/>
+        </p:nvSpPr>
+        <p:spPr>
+          <a:xfrm>
+            <a:off x="485775" y="2244923"/>
+            <a:ext cx="2692896" cy="19050"/>
+          </a:xfrm>
+          <a:prstGeom prst="rect">
+            <a:avLst/>
+          </a:prstGeom>
+          <a:solidFill>
+            <a:srgbClr val="C5A059"/>
+          </a:solidFill>
+          <a:ln>
+            <a:noFill/>
+          </a:ln>
+        </p:spPr>
+        <p:txBody>
+          <a:bodyPr anchorCtr="0" anchor="ctr" bIns="45700" lIns="91425" spcFirstLastPara="1" rIns="91425" wrap="square" tIns="45700">
+            <a:noAutofit/>
+          </a:bodyPr>
+          <a:lstStyle/>
+          <a:p>
+            <a:pPr indent="0" lvl="0" marL="0" marR="0" rtl="0" algn="ctr">
+              <a:spcBef>
+                <a:spcPts val="0"/>
+              </a:spcBef>
+              <a:spcAft>
+                <a:spcPts val="0"/>
+              </a:spcAft>
+              <a:buNone/>
+            </a:pPr>
+            <a:r>
+              <a:t/>
+            </a:r>
+            <a:endParaRPr b="0" i="0" sz="1800" u="none" cap="none" strike="noStrike">
+              <a:solidFill>
+                <a:schemeClr val="dk1"/>
+              </a:solidFill>
+              <a:latin typeface="Calibri"/>
+              <a:ea typeface="Calibri"/>
+              <a:cs typeface="Calibri"/>
+              <a:sym typeface="Calibri"/>
+            </a:endParaRPr>
+          </a:p>
+        </p:txBody>
+      </p:sp>
+      <p:sp>
+        <p:nvSpPr>
+          <p:cNvPr id="346" name="Google Shape;346;p9"/>
+          <p:cNvSpPr/>
+          <p:nvPr/>
+        </p:nvSpPr>
+        <p:spPr>
+          <a:xfrm>
+            <a:off x="3178671" y="2244923"/>
+            <a:ext cx="1346448" cy="19050"/>
+          </a:xfrm>
+          <a:prstGeom prst="rect">
+            <a:avLst/>
+          </a:prstGeom>
+          <a:solidFill>
+            <a:srgbClr val="C5A059"/>
+          </a:solidFill>
+          <a:ln>
+            <a:noFill/>
+          </a:ln>
+        </p:spPr>
+        <p:txBody>
+          <a:bodyPr anchorCtr="0" anchor="ctr" bIns="45700" lIns="91425" spcFirstLastPara="1" rIns="91425" wrap="square" tIns="45700">
+            <a:noAutofit/>
+          </a:bodyPr>
+          <a:lstStyle/>
+          <a:p>
+            <a:pPr indent="0" lvl="0" marL="0" marR="0" rtl="0" algn="ctr">
+              <a:spcBef>
+                <a:spcPts val="0"/>
+              </a:spcBef>
+              <a:spcAft>
+                <a:spcPts val="0"/>
+              </a:spcAft>
+              <a:buNone/>
+            </a:pPr>
+            <a:r>
+              <a:t/>
+            </a:r>
+            <a:endParaRPr b="0" i="0" sz="1800" u="none" cap="none" strike="noStrike">
+              <a:solidFill>
+                <a:schemeClr val="dk1"/>
+              </a:solidFill>
+              <a:latin typeface="Calibri"/>
+              <a:ea typeface="Calibri"/>
+              <a:cs typeface="Calibri"/>
+              <a:sym typeface="Calibri"/>
+            </a:endParaRPr>
+          </a:p>
+        </p:txBody>
+      </p:sp>
+      <p:sp>
+        <p:nvSpPr>
+          <p:cNvPr id="347" name="Google Shape;347;p9"/>
+          <p:cNvSpPr/>
+          <p:nvPr/>
+        </p:nvSpPr>
+        <p:spPr>
+          <a:xfrm>
+            <a:off x="4525119" y="2244923"/>
+            <a:ext cx="3141612" cy="19050"/>
+          </a:xfrm>
+          <a:prstGeom prst="rect">
+            <a:avLst/>
+          </a:prstGeom>
+          <a:solidFill>
+            <a:srgbClr val="C5A059"/>
+          </a:solidFill>
+          <a:ln>
+            <a:noFill/>
+          </a:ln>
+        </p:spPr>
+        <p:txBody>
+          <a:bodyPr anchorCtr="0" anchor="ctr" bIns="45700" lIns="91425" spcFirstLastPara="1" rIns="91425" wrap="square" tIns="45700">
+            <a:noAutofit/>
+          </a:bodyPr>
+          <a:lstStyle/>
+          <a:p>
+            <a:pPr indent="0" lvl="0" marL="0" marR="0" rtl="0" algn="ctr">
+              <a:spcBef>
+                <a:spcPts val="0"/>
+              </a:spcBef>
+              <a:spcAft>
+                <a:spcPts val="0"/>
+              </a:spcAft>
+              <a:buNone/>
+            </a:pPr>
+            <a:r>
+              <a:t/>
+            </a:r>
+            <a:endParaRPr b="0" i="0" sz="1800" u="none" cap="none" strike="noStrike">
+              <a:solidFill>
+                <a:schemeClr val="dk1"/>
+              </a:solidFill>
+              <a:latin typeface="Calibri"/>
+              <a:ea typeface="Calibri"/>
+              <a:cs typeface="Calibri"/>
+              <a:sym typeface="Calibri"/>
+            </a:endParaRPr>
+          </a:p>
+        </p:txBody>
+      </p:sp>
+      <p:sp>
+        <p:nvSpPr>
+          <p:cNvPr id="348" name="Google Shape;348;p9"/>
+          <p:cNvSpPr/>
+          <p:nvPr/>
+        </p:nvSpPr>
+        <p:spPr>
+          <a:xfrm>
+            <a:off x="7666732" y="2244923"/>
+            <a:ext cx="4039492" cy="19050"/>
+          </a:xfrm>
+          <a:prstGeom prst="rect">
+            <a:avLst/>
+          </a:prstGeom>
+          <a:solidFill>
+            <a:srgbClr val="C5A059"/>
+          </a:solidFill>
+          <a:ln>
+            <a:noFill/>
+          </a:ln>
+        </p:spPr>
+        <p:txBody>
+          <a:bodyPr anchorCtr="0" anchor="ctr" bIns="45700" lIns="91425" spcFirstLastPara="1" rIns="91425" wrap="square" tIns="45700">
+            <a:noAutofit/>
+          </a:bodyPr>
+          <a:lstStyle/>
+          <a:p>
+            <a:pPr indent="0" lvl="0" marL="0" marR="0" rtl="0" algn="ctr">
+              <a:spcBef>
+                <a:spcPts val="0"/>
+              </a:spcBef>
+              <a:spcAft>
+                <a:spcPts val="0"/>
+              </a:spcAft>
+              <a:buNone/>
+            </a:pPr>
+            <a:r>
+              <a:t/>
+            </a:r>
+            <a:endParaRPr b="0" i="0" sz="1800" u="none" cap="none" strike="noStrike">
+              <a:solidFill>
+                <a:schemeClr val="dk1"/>
+              </a:solidFill>
+              <a:latin typeface="Calibri"/>
+              <a:ea typeface="Calibri"/>
+              <a:cs typeface="Calibri"/>
+              <a:sym typeface="Calibri"/>
+            </a:endParaRPr>
+          </a:p>
+        </p:txBody>
+      </p:sp>
+      <p:sp>
+        <p:nvSpPr>
+          <p:cNvPr id="349" name="Google Shape;349;p9"/>
+          <p:cNvSpPr/>
+          <p:nvPr/>
+        </p:nvSpPr>
+        <p:spPr>
+          <a:xfrm>
+            <a:off x="485775" y="2878335"/>
+            <a:ext cx="2692896" cy="9525"/>
+          </a:xfrm>
+          <a:prstGeom prst="rect">
+            <a:avLst/>
+          </a:prstGeom>
+          <a:solidFill>
+            <a:srgbClr val="F3ECE0"/>
+          </a:solidFill>
+          <a:ln>
+            <a:noFill/>
+          </a:ln>
+        </p:spPr>
+        <p:txBody>
+          <a:bodyPr anchorCtr="0" anchor="ctr" bIns="45700" lIns="91425" spcFirstLastPara="1" rIns="91425" wrap="square" tIns="45700">
+            <a:noAutofit/>
+          </a:bodyPr>
+          <a:lstStyle/>
+          <a:p>
+            <a:pPr indent="0" lvl="0" marL="0" marR="0" rtl="0" algn="ctr">
+              <a:spcBef>
+                <a:spcPts val="0"/>
+              </a:spcBef>
+              <a:spcAft>
+                <a:spcPts val="0"/>
+              </a:spcAft>
+              <a:buNone/>
+            </a:pPr>
+            <a:r>
+              <a:t/>
+            </a:r>
+            <a:endParaRPr b="0" i="0" sz="1800" u="none" cap="none" strike="noStrike">
+              <a:solidFill>
+                <a:schemeClr val="dk1"/>
+              </a:solidFill>
+              <a:latin typeface="Calibri"/>
+              <a:ea typeface="Calibri"/>
+              <a:cs typeface="Calibri"/>
+              <a:sym typeface="Calibri"/>
+            </a:endParaRPr>
+          </a:p>
+        </p:txBody>
+      </p:sp>
+      <p:sp>
+        <p:nvSpPr>
+          <p:cNvPr id="350" name="Google Shape;350;p9"/>
+          <p:cNvSpPr/>
+          <p:nvPr/>
+        </p:nvSpPr>
+        <p:spPr>
+          <a:xfrm>
+            <a:off x="3178671" y="2878335"/>
+            <a:ext cx="1346448" cy="9525"/>
+          </a:xfrm>
+          <a:prstGeom prst="rect">
+            <a:avLst/>
+          </a:prstGeom>
+          <a:solidFill>
+            <a:srgbClr val="F3ECE0"/>
+          </a:solidFill>
+          <a:ln>
+            <a:noFill/>
+          </a:ln>
+        </p:spPr>
+        <p:txBody>
+          <a:bodyPr anchorCtr="0" anchor="ctr" bIns="45700" lIns="91425" spcFirstLastPara="1" rIns="91425" wrap="square" tIns="45700">
+            <a:noAutofit/>
+          </a:bodyPr>
+          <a:lstStyle/>
+          <a:p>
+            <a:pPr indent="0" lvl="0" marL="0" marR="0" rtl="0" algn="ctr">
+              <a:spcBef>
+                <a:spcPts val="0"/>
+              </a:spcBef>
+              <a:spcAft>
+                <a:spcPts val="0"/>
+              </a:spcAft>
+              <a:buNone/>
+            </a:pPr>
+            <a:r>
+              <a:t/>
+            </a:r>
+            <a:endParaRPr b="0" i="0" sz="1800" u="none" cap="none" strike="noStrike">
+              <a:solidFill>
+                <a:schemeClr val="dk1"/>
+              </a:solidFill>
+              <a:latin typeface="Calibri"/>
+              <a:ea typeface="Calibri"/>
+              <a:cs typeface="Calibri"/>
+              <a:sym typeface="Calibri"/>
+            </a:endParaRPr>
+          </a:p>
+        </p:txBody>
+      </p:sp>
+      <p:sp>
+        <p:nvSpPr>
+          <p:cNvPr id="351" name="Google Shape;351;p9"/>
+          <p:cNvSpPr/>
+          <p:nvPr/>
+        </p:nvSpPr>
+        <p:spPr>
+          <a:xfrm>
+            <a:off x="4525119" y="2878335"/>
+            <a:ext cx="3141612" cy="9525"/>
+          </a:xfrm>
+          <a:prstGeom prst="rect">
+            <a:avLst/>
+          </a:prstGeom>
+          <a:solidFill>
+            <a:srgbClr val="F3ECE0"/>
+          </a:solidFill>
+          <a:ln>
+            <a:noFill/>
+          </a:ln>
+        </p:spPr>
+        <p:txBody>
+          <a:bodyPr anchorCtr="0" anchor="ctr" bIns="45700" lIns="91425" spcFirstLastPara="1" rIns="91425" wrap="square" tIns="45700">
+            <a:noAutofit/>
+          </a:bodyPr>
+          <a:lstStyle/>
+          <a:p>
+            <a:pPr indent="0" lvl="0" marL="0" marR="0" rtl="0" algn="ctr">
+              <a:spcBef>
+                <a:spcPts val="0"/>
+              </a:spcBef>
+              <a:spcAft>
+                <a:spcPts val="0"/>
+              </a:spcAft>
+              <a:buNone/>
+            </a:pPr>
+            <a:r>
+              <a:t/>
+            </a:r>
+            <a:endParaRPr b="0" i="0" sz="1800" u="none" cap="none" strike="noStrike">
+              <a:solidFill>
+                <a:schemeClr val="dk1"/>
+              </a:solidFill>
+              <a:latin typeface="Calibri"/>
+              <a:ea typeface="Calibri"/>
+              <a:cs typeface="Calibri"/>
+              <a:sym typeface="Calibri"/>
+            </a:endParaRPr>
+          </a:p>
+        </p:txBody>
+      </p:sp>
+      <p:sp>
+        <p:nvSpPr>
           <p:cNvPr id="352" name="Google Shape;352;p9"/>
           <p:cNvSpPr/>
           <p:nvPr/>
         </p:nvSpPr>
         <p:spPr>
           <a:xfrm>
-            <a:off x="485775" y="2244923"/>
-            <a:ext cx="2692896" cy="19050"/>
+            <a:off x="7666732" y="2878335"/>
+            <a:ext cx="4039492" cy="9525"/>
           </a:xfrm>
           <a:prstGeom prst="rect">
             <a:avLst/>
           </a:prstGeom>
           <a:solidFill>
-            <a:srgbClr val="C5A059"/>
+            <a:srgbClr val="F3ECE0"/>
           </a:solidFill>
           <a:ln>
             <a:noFill/>
@@ -26955,14 +27123,14 @@
         </p:nvSpPr>
         <p:spPr>
           <a:xfrm>
-            <a:off x="3178671" y="2244923"/>
-            <a:ext cx="1346448" cy="19050"/>
+            <a:off x="485775" y="3554610"/>
+            <a:ext cx="2692896" cy="9525"/>
           </a:xfrm>
           <a:prstGeom prst="rect">
             <a:avLst/>
           </a:prstGeom>
           <a:solidFill>
-            <a:srgbClr val="C5A059"/>
+            <a:srgbClr val="F3ECE0"/>
           </a:solidFill>
           <a:ln>
             <a:noFill/>
@@ -27006,14 +27174,14 @@
         </p:nvSpPr>
         <p:spPr>
           <a:xfrm>
-            <a:off x="4525119" y="2244923"/>
-            <a:ext cx="3141612" cy="19050"/>
+            <a:off x="3178671" y="3554610"/>
+            <a:ext cx="1346448" cy="9525"/>
           </a:xfrm>
           <a:prstGeom prst="rect">
             <a:avLst/>
           </a:prstGeom>
           <a:solidFill>
-            <a:srgbClr val="C5A059"/>
+            <a:srgbClr val="F3ECE0"/>
           </a:solidFill>
           <a:ln>
             <a:noFill/>
@@ -27057,14 +27225,14 @@
         </p:nvSpPr>
         <p:spPr>
           <a:xfrm>
-            <a:off x="7666732" y="2244923"/>
-            <a:ext cx="4039492" cy="19050"/>
+            <a:off x="4525119" y="3554610"/>
+            <a:ext cx="3141612" cy="9525"/>
           </a:xfrm>
           <a:prstGeom prst="rect">
             <a:avLst/>
           </a:prstGeom>
           <a:solidFill>
-            <a:srgbClr val="C5A059"/>
+            <a:srgbClr val="F3ECE0"/>
           </a:solidFill>
           <a:ln>
             <a:noFill/>
@@ -27108,8 +27276,8 @@
         </p:nvSpPr>
         <p:spPr>
           <a:xfrm>
-            <a:off x="485775" y="2878335"/>
-            <a:ext cx="2692896" cy="9525"/>
+            <a:off x="7666732" y="3554610"/>
+            <a:ext cx="4039492" cy="9525"/>
           </a:xfrm>
           <a:prstGeom prst="rect">
             <a:avLst/>
@@ -27159,8 +27327,8 @@
         </p:nvSpPr>
         <p:spPr>
           <a:xfrm>
-            <a:off x="3178671" y="2878335"/>
-            <a:ext cx="1346448" cy="9525"/>
+            <a:off x="485775" y="4230885"/>
+            <a:ext cx="2692896" cy="9525"/>
           </a:xfrm>
           <a:prstGeom prst="rect">
             <a:avLst/>
@@ -27210,8 +27378,8 @@
         </p:nvSpPr>
         <p:spPr>
           <a:xfrm>
-            <a:off x="4525119" y="2878335"/>
-            <a:ext cx="3141612" cy="9525"/>
+            <a:off x="3178671" y="4230885"/>
+            <a:ext cx="1346448" cy="9525"/>
           </a:xfrm>
           <a:prstGeom prst="rect">
             <a:avLst/>
@@ -27261,8 +27429,8 @@
         </p:nvSpPr>
         <p:spPr>
           <a:xfrm>
-            <a:off x="7666732" y="2878335"/>
-            <a:ext cx="4039492" cy="9525"/>
+            <a:off x="4525119" y="4230885"/>
+            <a:ext cx="3141612" cy="9525"/>
           </a:xfrm>
           <a:prstGeom prst="rect">
             <a:avLst/>
@@ -27312,8 +27480,8 @@
         </p:nvSpPr>
         <p:spPr>
           <a:xfrm>
-            <a:off x="485775" y="3554610"/>
-            <a:ext cx="2692896" cy="9525"/>
+            <a:off x="7666732" y="4230885"/>
+            <a:ext cx="4039492" cy="9525"/>
           </a:xfrm>
           <a:prstGeom prst="rect">
             <a:avLst/>
@@ -27363,8 +27531,8 @@
         </p:nvSpPr>
         <p:spPr>
           <a:xfrm>
-            <a:off x="3178671" y="3554610"/>
-            <a:ext cx="1346448" cy="9525"/>
+            <a:off x="485775" y="4907160"/>
+            <a:ext cx="2692896" cy="9525"/>
           </a:xfrm>
           <a:prstGeom prst="rect">
             <a:avLst/>
@@ -27414,8 +27582,8 @@
         </p:nvSpPr>
         <p:spPr>
           <a:xfrm>
-            <a:off x="4525119" y="3554610"/>
-            <a:ext cx="3141612" cy="9525"/>
+            <a:off x="3178671" y="4907160"/>
+            <a:ext cx="1346448" cy="9525"/>
           </a:xfrm>
           <a:prstGeom prst="rect">
             <a:avLst/>
@@ -27465,8 +27633,8 @@
         </p:nvSpPr>
         <p:spPr>
           <a:xfrm>
-            <a:off x="7666732" y="3554610"/>
-            <a:ext cx="4039492" cy="9525"/>
+            <a:off x="4525119" y="4907160"/>
+            <a:ext cx="3141612" cy="9525"/>
           </a:xfrm>
           <a:prstGeom prst="rect">
             <a:avLst/>
@@ -27516,8 +27684,8 @@
         </p:nvSpPr>
         <p:spPr>
           <a:xfrm>
-            <a:off x="485775" y="4230885"/>
-            <a:ext cx="2692896" cy="9525"/>
+            <a:off x="7666732" y="4907160"/>
+            <a:ext cx="4039492" cy="9525"/>
           </a:xfrm>
           <a:prstGeom prst="rect">
             <a:avLst/>
@@ -27562,363 +27730,6 @@
       <p:sp>
         <p:nvSpPr>
           <p:cNvPr id="365" name="Google Shape;365;p9"/>
-          <p:cNvSpPr/>
-          <p:nvPr/>
-        </p:nvSpPr>
-        <p:spPr>
-          <a:xfrm>
-            <a:off x="3178671" y="4230885"/>
-            <a:ext cx="1346448" cy="9525"/>
-          </a:xfrm>
-          <a:prstGeom prst="rect">
-            <a:avLst/>
-          </a:prstGeom>
-          <a:solidFill>
-            <a:srgbClr val="F3ECE0"/>
-          </a:solidFill>
-          <a:ln>
-            <a:noFill/>
-          </a:ln>
-        </p:spPr>
-        <p:txBody>
-          <a:bodyPr anchorCtr="0" anchor="ctr" bIns="45700" lIns="91425" spcFirstLastPara="1" rIns="91425" wrap="square" tIns="45700">
-            <a:noAutofit/>
-          </a:bodyPr>
-          <a:lstStyle/>
-          <a:p>
-            <a:pPr indent="0" lvl="0" marL="0" marR="0" rtl="0" algn="ctr">
-              <a:spcBef>
-                <a:spcPts val="0"/>
-              </a:spcBef>
-              <a:spcAft>
-                <a:spcPts val="0"/>
-              </a:spcAft>
-              <a:buNone/>
-            </a:pPr>
-            <a:r>
-              <a:t/>
-            </a:r>
-            <a:endParaRPr b="0" i="0" sz="1800" u="none" cap="none" strike="noStrike">
-              <a:solidFill>
-                <a:schemeClr val="dk1"/>
-              </a:solidFill>
-              <a:latin typeface="Calibri"/>
-              <a:ea typeface="Calibri"/>
-              <a:cs typeface="Calibri"/>
-              <a:sym typeface="Calibri"/>
-            </a:endParaRPr>
-          </a:p>
-        </p:txBody>
-      </p:sp>
-      <p:sp>
-        <p:nvSpPr>
-          <p:cNvPr id="366" name="Google Shape;366;p9"/>
-          <p:cNvSpPr/>
-          <p:nvPr/>
-        </p:nvSpPr>
-        <p:spPr>
-          <a:xfrm>
-            <a:off x="4525119" y="4230885"/>
-            <a:ext cx="3141612" cy="9525"/>
-          </a:xfrm>
-          <a:prstGeom prst="rect">
-            <a:avLst/>
-          </a:prstGeom>
-          <a:solidFill>
-            <a:srgbClr val="F3ECE0"/>
-          </a:solidFill>
-          <a:ln>
-            <a:noFill/>
-          </a:ln>
-        </p:spPr>
-        <p:txBody>
-          <a:bodyPr anchorCtr="0" anchor="ctr" bIns="45700" lIns="91425" spcFirstLastPara="1" rIns="91425" wrap="square" tIns="45700">
-            <a:noAutofit/>
-          </a:bodyPr>
-          <a:lstStyle/>
-          <a:p>
-            <a:pPr indent="0" lvl="0" marL="0" marR="0" rtl="0" algn="ctr">
-              <a:spcBef>
-                <a:spcPts val="0"/>
-              </a:spcBef>
-              <a:spcAft>
-                <a:spcPts val="0"/>
-              </a:spcAft>
-              <a:buNone/>
-            </a:pPr>
-            <a:r>
-              <a:t/>
-            </a:r>
-            <a:endParaRPr b="0" i="0" sz="1800" u="none" cap="none" strike="noStrike">
-              <a:solidFill>
-                <a:schemeClr val="dk1"/>
-              </a:solidFill>
-              <a:latin typeface="Calibri"/>
-              <a:ea typeface="Calibri"/>
-              <a:cs typeface="Calibri"/>
-              <a:sym typeface="Calibri"/>
-            </a:endParaRPr>
-          </a:p>
-        </p:txBody>
-      </p:sp>
-      <p:sp>
-        <p:nvSpPr>
-          <p:cNvPr id="367" name="Google Shape;367;p9"/>
-          <p:cNvSpPr/>
-          <p:nvPr/>
-        </p:nvSpPr>
-        <p:spPr>
-          <a:xfrm>
-            <a:off x="7666732" y="4230885"/>
-            <a:ext cx="4039492" cy="9525"/>
-          </a:xfrm>
-          <a:prstGeom prst="rect">
-            <a:avLst/>
-          </a:prstGeom>
-          <a:solidFill>
-            <a:srgbClr val="F3ECE0"/>
-          </a:solidFill>
-          <a:ln>
-            <a:noFill/>
-          </a:ln>
-        </p:spPr>
-        <p:txBody>
-          <a:bodyPr anchorCtr="0" anchor="ctr" bIns="45700" lIns="91425" spcFirstLastPara="1" rIns="91425" wrap="square" tIns="45700">
-            <a:noAutofit/>
-          </a:bodyPr>
-          <a:lstStyle/>
-          <a:p>
-            <a:pPr indent="0" lvl="0" marL="0" marR="0" rtl="0" algn="ctr">
-              <a:spcBef>
-                <a:spcPts val="0"/>
-              </a:spcBef>
-              <a:spcAft>
-                <a:spcPts val="0"/>
-              </a:spcAft>
-              <a:buNone/>
-            </a:pPr>
-            <a:r>
-              <a:t/>
-            </a:r>
-            <a:endParaRPr b="0" i="0" sz="1800" u="none" cap="none" strike="noStrike">
-              <a:solidFill>
-                <a:schemeClr val="dk1"/>
-              </a:solidFill>
-              <a:latin typeface="Calibri"/>
-              <a:ea typeface="Calibri"/>
-              <a:cs typeface="Calibri"/>
-              <a:sym typeface="Calibri"/>
-            </a:endParaRPr>
-          </a:p>
-        </p:txBody>
-      </p:sp>
-      <p:sp>
-        <p:nvSpPr>
-          <p:cNvPr id="368" name="Google Shape;368;p9"/>
-          <p:cNvSpPr/>
-          <p:nvPr/>
-        </p:nvSpPr>
-        <p:spPr>
-          <a:xfrm>
-            <a:off x="485775" y="4907160"/>
-            <a:ext cx="2692896" cy="9525"/>
-          </a:xfrm>
-          <a:prstGeom prst="rect">
-            <a:avLst/>
-          </a:prstGeom>
-          <a:solidFill>
-            <a:srgbClr val="F3ECE0"/>
-          </a:solidFill>
-          <a:ln>
-            <a:noFill/>
-          </a:ln>
-        </p:spPr>
-        <p:txBody>
-          <a:bodyPr anchorCtr="0" anchor="ctr" bIns="45700" lIns="91425" spcFirstLastPara="1" rIns="91425" wrap="square" tIns="45700">
-            <a:noAutofit/>
-          </a:bodyPr>
-          <a:lstStyle/>
-          <a:p>
-            <a:pPr indent="0" lvl="0" marL="0" marR="0" rtl="0" algn="ctr">
-              <a:spcBef>
-                <a:spcPts val="0"/>
-              </a:spcBef>
-              <a:spcAft>
-                <a:spcPts val="0"/>
-              </a:spcAft>
-              <a:buNone/>
-            </a:pPr>
-            <a:r>
-              <a:t/>
-            </a:r>
-            <a:endParaRPr b="0" i="0" sz="1800" u="none" cap="none" strike="noStrike">
-              <a:solidFill>
-                <a:schemeClr val="dk1"/>
-              </a:solidFill>
-              <a:latin typeface="Calibri"/>
-              <a:ea typeface="Calibri"/>
-              <a:cs typeface="Calibri"/>
-              <a:sym typeface="Calibri"/>
-            </a:endParaRPr>
-          </a:p>
-        </p:txBody>
-      </p:sp>
-      <p:sp>
-        <p:nvSpPr>
-          <p:cNvPr id="369" name="Google Shape;369;p9"/>
-          <p:cNvSpPr/>
-          <p:nvPr/>
-        </p:nvSpPr>
-        <p:spPr>
-          <a:xfrm>
-            <a:off x="3178671" y="4907160"/>
-            <a:ext cx="1346448" cy="9525"/>
-          </a:xfrm>
-          <a:prstGeom prst="rect">
-            <a:avLst/>
-          </a:prstGeom>
-          <a:solidFill>
-            <a:srgbClr val="F3ECE0"/>
-          </a:solidFill>
-          <a:ln>
-            <a:noFill/>
-          </a:ln>
-        </p:spPr>
-        <p:txBody>
-          <a:bodyPr anchorCtr="0" anchor="ctr" bIns="45700" lIns="91425" spcFirstLastPara="1" rIns="91425" wrap="square" tIns="45700">
-            <a:noAutofit/>
-          </a:bodyPr>
-          <a:lstStyle/>
-          <a:p>
-            <a:pPr indent="0" lvl="0" marL="0" marR="0" rtl="0" algn="ctr">
-              <a:spcBef>
-                <a:spcPts val="0"/>
-              </a:spcBef>
-              <a:spcAft>
-                <a:spcPts val="0"/>
-              </a:spcAft>
-              <a:buNone/>
-            </a:pPr>
-            <a:r>
-              <a:t/>
-            </a:r>
-            <a:endParaRPr b="0" i="0" sz="1800" u="none" cap="none" strike="noStrike">
-              <a:solidFill>
-                <a:schemeClr val="dk1"/>
-              </a:solidFill>
-              <a:latin typeface="Calibri"/>
-              <a:ea typeface="Calibri"/>
-              <a:cs typeface="Calibri"/>
-              <a:sym typeface="Calibri"/>
-            </a:endParaRPr>
-          </a:p>
-        </p:txBody>
-      </p:sp>
-      <p:sp>
-        <p:nvSpPr>
-          <p:cNvPr id="370" name="Google Shape;370;p9"/>
-          <p:cNvSpPr/>
-          <p:nvPr/>
-        </p:nvSpPr>
-        <p:spPr>
-          <a:xfrm>
-            <a:off x="4525119" y="4907160"/>
-            <a:ext cx="3141612" cy="9525"/>
-          </a:xfrm>
-          <a:prstGeom prst="rect">
-            <a:avLst/>
-          </a:prstGeom>
-          <a:solidFill>
-            <a:srgbClr val="F3ECE0"/>
-          </a:solidFill>
-          <a:ln>
-            <a:noFill/>
-          </a:ln>
-        </p:spPr>
-        <p:txBody>
-          <a:bodyPr anchorCtr="0" anchor="ctr" bIns="45700" lIns="91425" spcFirstLastPara="1" rIns="91425" wrap="square" tIns="45700">
-            <a:noAutofit/>
-          </a:bodyPr>
-          <a:lstStyle/>
-          <a:p>
-            <a:pPr indent="0" lvl="0" marL="0" marR="0" rtl="0" algn="ctr">
-              <a:spcBef>
-                <a:spcPts val="0"/>
-              </a:spcBef>
-              <a:spcAft>
-                <a:spcPts val="0"/>
-              </a:spcAft>
-              <a:buNone/>
-            </a:pPr>
-            <a:r>
-              <a:t/>
-            </a:r>
-            <a:endParaRPr b="0" i="0" sz="1800" u="none" cap="none" strike="noStrike">
-              <a:solidFill>
-                <a:schemeClr val="dk1"/>
-              </a:solidFill>
-              <a:latin typeface="Calibri"/>
-              <a:ea typeface="Calibri"/>
-              <a:cs typeface="Calibri"/>
-              <a:sym typeface="Calibri"/>
-            </a:endParaRPr>
-          </a:p>
-        </p:txBody>
-      </p:sp>
-      <p:sp>
-        <p:nvSpPr>
-          <p:cNvPr id="371" name="Google Shape;371;p9"/>
-          <p:cNvSpPr/>
-          <p:nvPr/>
-        </p:nvSpPr>
-        <p:spPr>
-          <a:xfrm>
-            <a:off x="7666732" y="4907160"/>
-            <a:ext cx="4039492" cy="9525"/>
-          </a:xfrm>
-          <a:prstGeom prst="rect">
-            <a:avLst/>
-          </a:prstGeom>
-          <a:solidFill>
-            <a:srgbClr val="F3ECE0"/>
-          </a:solidFill>
-          <a:ln>
-            <a:noFill/>
-          </a:ln>
-        </p:spPr>
-        <p:txBody>
-          <a:bodyPr anchorCtr="0" anchor="ctr" bIns="45700" lIns="91425" spcFirstLastPara="1" rIns="91425" wrap="square" tIns="45700">
-            <a:noAutofit/>
-          </a:bodyPr>
-          <a:lstStyle/>
-          <a:p>
-            <a:pPr indent="0" lvl="0" marL="0" marR="0" rtl="0" algn="ctr">
-              <a:spcBef>
-                <a:spcPts val="0"/>
-              </a:spcBef>
-              <a:spcAft>
-                <a:spcPts val="0"/>
-              </a:spcAft>
-              <a:buNone/>
-            </a:pPr>
-            <a:r>
-              <a:t/>
-            </a:r>
-            <a:endParaRPr b="0" i="0" sz="1800" u="none" cap="none" strike="noStrike">
-              <a:solidFill>
-                <a:schemeClr val="dk1"/>
-              </a:solidFill>
-              <a:latin typeface="Calibri"/>
-              <a:ea typeface="Calibri"/>
-              <a:cs typeface="Calibri"/>
-              <a:sym typeface="Calibri"/>
-            </a:endParaRPr>
-          </a:p>
-        </p:txBody>
-      </p:sp>
-      <p:sp>
-        <p:nvSpPr>
-          <p:cNvPr id="372" name="Google Shape;372;p9"/>
           <p:cNvSpPr txBox="1"/>
           <p:nvPr/>
         </p:nvSpPr>
@@ -27980,7 +27791,7 @@
       </p:sp>
       <p:sp>
         <p:nvSpPr>
-          <p:cNvPr id="373" name="Google Shape;373;p9"/>
+          <p:cNvPr id="366" name="Google Shape;366;p9"/>
           <p:cNvSpPr txBox="1"/>
           <p:nvPr/>
         </p:nvSpPr>

</xml_diff>